<commit_message>
Mostra os apresentadores apenas na capa
Remove o "Apresentado por" do cabeçalho dos slides de conteúdo e do
slide final, mantendo os nomes somente no primeiro slide.

Co-Authored-By: Claude Opus 5.5 <noreply@anthropic.com>
Claude-Session: https://claude.ai/code/session_01JxDR9SBozuetufXLyUfjgu
</commit_message>
<xml_diff>
--- a/apresentacoes/salmonella/Salmonella_Apresentacao.pptx
+++ b/apresentacoes/salmonella/Salmonella_Apresentacao.pptx
@@ -4912,65 +4912,7 @@
       </p:grpSp>
       <p:sp>
         <p:nvSpPr>
-          <p:cNvPr id="101" name="Cabeçalho 101"/>
-          <p:cNvSpPr txBox="1"/>
-          <p:nvPr/>
-        </p:nvSpPr>
-        <p:spPr>
-          <a:xfrm>
-            <a:off x="1024128" y="932688"/>
-            <a:ext cx="13533120" cy="411480"/>
-          </a:xfrm>
-          <a:prstGeom prst="rect">
-            <a:avLst/>
-          </a:prstGeom>
-          <a:noFill/>
-        </p:spPr>
-        <p:txBody>
-          <a:bodyPr wrap="square" lIns="0" tIns="0" rIns="0" bIns="0" anchor="t" rtlCol="0">
-            <a:noAutofit/>
-          </a:bodyPr>
-          <a:lstStyle/>
-          <a:p>
-            <a:pPr algn="l">
-              <a:spcBef>
-                <a:spcPts val="0"/>
-              </a:spcBef>
-              <a:spcAft>
-                <a:spcPts val="0"/>
-              </a:spcAft>
-              <a:buNone/>
-            </a:pPr>
-            <a:r>
-              <a:rPr lang="pt-BR" sz="1900">
-                <a:solidFill>
-                  <a:srgbClr val="3E721D"/>
-                </a:solidFill>
-                <a:latin typeface="Garet"/>
-                <a:ea typeface="Garet"/>
-                <a:cs typeface="Garet"/>
-                <a:sym typeface="Garet"/>
-              </a:rPr>
-              <a:t xml:space="preserve">Apresentado por  </a:t>
-            </a:r>
-            <a:r>
-              <a:rPr lang="pt-BR" sz="1900" b="1">
-                <a:solidFill>
-                  <a:srgbClr val="3E721D"/>
-                </a:solidFill>
-                <a:latin typeface="Garet Bold"/>
-                <a:ea typeface="Garet Bold"/>
-                <a:cs typeface="Garet Bold"/>
-                <a:sym typeface="Garet Bold"/>
-              </a:rPr>
-              <a:t>Matheus Rosa, Gabriely Paixão, Yvana Lopes, Milena Vitória e Myriam Caires</a:t>
-            </a:r>
-          </a:p>
-        </p:txBody>
-      </p:sp>
-      <p:sp>
-        <p:nvSpPr>
-          <p:cNvPr id="102" name="Ano 102"/>
+          <p:cNvPr id="101" name="Ano 101"/>
           <p:cNvSpPr txBox="1"/>
           <p:nvPr/>
         </p:nvSpPr>
@@ -5016,7 +4958,7 @@
       </p:sp>
       <p:sp>
         <p:nvSpPr>
-          <p:cNvPr id="103" name="Rodapé 103"/>
+          <p:cNvPr id="102" name="Rodapé 102"/>
           <p:cNvSpPr txBox="1"/>
           <p:nvPr/>
         </p:nvSpPr>
@@ -5062,7 +5004,7 @@
       </p:sp>
       <p:sp>
         <p:nvSpPr>
-          <p:cNvPr id="104" name="Página 104"/>
+          <p:cNvPr id="103" name="Página 103"/>
           <p:cNvSpPr txBox="1"/>
           <p:nvPr/>
         </p:nvSpPr>
@@ -5108,7 +5050,7 @@
       </p:sp>
       <p:sp>
         <p:nvSpPr>
-          <p:cNvPr id="105" name="Título 105"/>
+          <p:cNvPr id="104" name="Título 104"/>
           <p:cNvSpPr txBox="1"/>
           <p:nvPr/>
         </p:nvSpPr>
@@ -5157,7 +5099,7 @@
       </p:sp>
       <p:grpSp>
         <p:nvGrpSpPr>
-          <p:cNvPr id="109" name="Coluna 109"/>
+          <p:cNvPr id="108" name="Coluna 108"/>
           <p:cNvGrpSpPr/>
           <p:nvPr/>
         </p:nvGrpSpPr>
@@ -5171,7 +5113,7 @@
         </p:grpSpPr>
         <p:sp>
           <p:nvSpPr>
-            <p:cNvPr id="106" name="Cartão 106"/>
+            <p:cNvPr id="105" name="Cartão 105"/>
             <p:cNvSpPr/>
             <p:nvPr/>
           </p:nvSpPr>
@@ -5203,7 +5145,7 @@
         </p:sp>
         <p:sp>
           <p:nvSpPr>
-            <p:cNvPr id="107" name="Texto 107"/>
+            <p:cNvPr id="106" name="Texto 106"/>
             <p:cNvSpPr txBox="1"/>
             <p:nvPr/>
           </p:nvSpPr>
@@ -5249,7 +5191,7 @@
         </p:sp>
         <p:sp>
           <p:nvSpPr>
-            <p:cNvPr id="108" name="Texto 108"/>
+            <p:cNvPr id="107" name="Texto 107"/>
             <p:cNvSpPr txBox="1"/>
             <p:nvPr/>
           </p:nvSpPr>
@@ -5325,7 +5267,7 @@
       </p:grpSp>
       <p:grpSp>
         <p:nvGrpSpPr>
-          <p:cNvPr id="113" name="Coluna 113"/>
+          <p:cNvPr id="112" name="Coluna 112"/>
           <p:cNvGrpSpPr/>
           <p:nvPr/>
         </p:nvGrpSpPr>
@@ -5339,7 +5281,7 @@
         </p:grpSpPr>
         <p:sp>
           <p:nvSpPr>
-            <p:cNvPr id="110" name="Cartão 110"/>
+            <p:cNvPr id="109" name="Cartão 109"/>
             <p:cNvSpPr/>
             <p:nvPr/>
           </p:nvSpPr>
@@ -5371,7 +5313,7 @@
         </p:sp>
         <p:sp>
           <p:nvSpPr>
-            <p:cNvPr id="111" name="Texto 111"/>
+            <p:cNvPr id="110" name="Texto 110"/>
             <p:cNvSpPr txBox="1"/>
             <p:nvPr/>
           </p:nvSpPr>
@@ -5417,7 +5359,7 @@
         </p:sp>
         <p:sp>
           <p:nvSpPr>
-            <p:cNvPr id="112" name="Texto 112"/>
+            <p:cNvPr id="111" name="Texto 111"/>
             <p:cNvSpPr txBox="1"/>
             <p:nvPr/>
           </p:nvSpPr>
@@ -5493,7 +5435,7 @@
       </p:grpSp>
       <p:grpSp>
         <p:nvGrpSpPr>
-          <p:cNvPr id="117" name="Coluna 117"/>
+          <p:cNvPr id="116" name="Coluna 116"/>
           <p:cNvGrpSpPr/>
           <p:nvPr/>
         </p:nvGrpSpPr>
@@ -5507,7 +5449,7 @@
         </p:grpSpPr>
         <p:sp>
           <p:nvSpPr>
-            <p:cNvPr id="114" name="Cartão 114"/>
+            <p:cNvPr id="113" name="Cartão 113"/>
             <p:cNvSpPr/>
             <p:nvPr/>
           </p:nvSpPr>
@@ -5539,7 +5481,7 @@
         </p:sp>
         <p:sp>
           <p:nvSpPr>
-            <p:cNvPr id="115" name="Texto 115"/>
+            <p:cNvPr id="114" name="Texto 114"/>
             <p:cNvSpPr txBox="1"/>
             <p:nvPr/>
           </p:nvSpPr>
@@ -5585,7 +5527,7 @@
         </p:sp>
         <p:sp>
           <p:nvSpPr>
-            <p:cNvPr id="116" name="Texto 116"/>
+            <p:cNvPr id="115" name="Texto 115"/>
             <p:cNvSpPr txBox="1"/>
             <p:nvPr/>
           </p:nvSpPr>
@@ -5661,7 +5603,7 @@
       </p:grpSp>
       <p:sp>
         <p:nvSpPr>
-          <p:cNvPr id="118" name="Nota 118"/>
+          <p:cNvPr id="117" name="Nota 117"/>
           <p:cNvSpPr txBox="1"/>
           <p:nvPr/>
         </p:nvSpPr>
@@ -5765,7 +5707,7 @@
                                           </p:stCondLst>
                                         </p:cTn>
                                         <p:tgtEl>
-                                          <p:spTgt spid="105"/>
+                                          <p:spTgt spid="104"/>
                                         </p:tgtEl>
                                         <p:attrNameLst>
                                           <p:attrName>style.visibility</p:attrName>
@@ -5779,7 +5721,7 @@
                                       <p:cBhvr>
                                         <p:cTn id="7" dur="700"/>
                                         <p:tgtEl>
-                                          <p:spTgt spid="105"/>
+                                          <p:spTgt spid="104"/>
                                         </p:tgtEl>
                                       </p:cBhvr>
                                     </p:animEffect>
@@ -5800,7 +5742,7 @@
                                           </p:stCondLst>
                                         </p:cTn>
                                         <p:tgtEl>
-                                          <p:spTgt spid="109"/>
+                                          <p:spTgt spid="108"/>
                                         </p:tgtEl>
                                         <p:attrNameLst>
                                           <p:attrName>style.visibility</p:attrName>
@@ -5814,7 +5756,7 @@
                                       <p:cBhvr>
                                         <p:cTn id="10" dur="700"/>
                                         <p:tgtEl>
-                                          <p:spTgt spid="109"/>
+                                          <p:spTgt spid="108"/>
                                         </p:tgtEl>
                                       </p:cBhvr>
                                     </p:animEffect>
@@ -5835,7 +5777,7 @@
                                           </p:stCondLst>
                                         </p:cTn>
                                         <p:tgtEl>
-                                          <p:spTgt spid="113"/>
+                                          <p:spTgt spid="112"/>
                                         </p:tgtEl>
                                         <p:attrNameLst>
                                           <p:attrName>style.visibility</p:attrName>
@@ -5849,7 +5791,7 @@
                                       <p:cBhvr>
                                         <p:cTn id="13" dur="700"/>
                                         <p:tgtEl>
-                                          <p:spTgt spid="113"/>
+                                          <p:spTgt spid="112"/>
                                         </p:tgtEl>
                                       </p:cBhvr>
                                     </p:animEffect>
@@ -5870,7 +5812,7 @@
                                           </p:stCondLst>
                                         </p:cTn>
                                         <p:tgtEl>
-                                          <p:spTgt spid="117"/>
+                                          <p:spTgt spid="116"/>
                                         </p:tgtEl>
                                         <p:attrNameLst>
                                           <p:attrName>style.visibility</p:attrName>
@@ -5884,7 +5826,7 @@
                                       <p:cBhvr>
                                         <p:cTn id="16" dur="700"/>
                                         <p:tgtEl>
-                                          <p:spTgt spid="117"/>
+                                          <p:spTgt spid="116"/>
                                         </p:tgtEl>
                                       </p:cBhvr>
                                     </p:animEffect>
@@ -5905,7 +5847,7 @@
                                           </p:stCondLst>
                                         </p:cTn>
                                         <p:tgtEl>
-                                          <p:spTgt spid="118"/>
+                                          <p:spTgt spid="117"/>
                                         </p:tgtEl>
                                         <p:attrNameLst>
                                           <p:attrName>style.visibility</p:attrName>
@@ -5919,7 +5861,7 @@
                                       <p:cBhvr>
                                         <p:cTn id="19" dur="700"/>
                                         <p:tgtEl>
-                                          <p:spTgt spid="118"/>
+                                          <p:spTgt spid="117"/>
                                         </p:tgtEl>
                                       </p:cBhvr>
                                     </p:animEffect>
@@ -5954,8 +5896,8 @@
       </p:par>
     </p:tnLst>
     <p:bldLst>
-      <p:bldP spid="105" grpId="0"/>
-      <p:bldP spid="118" grpId="0"/>
+      <p:bldP spid="104" grpId="0"/>
+      <p:bldP spid="117" grpId="0"/>
     </p:bldLst>
   </p:timing>
 </p:sld>
@@ -6625,65 +6567,7 @@
       </p:grpSp>
       <p:sp>
         <p:nvSpPr>
-          <p:cNvPr id="101" name="Cabeçalho 101"/>
-          <p:cNvSpPr txBox="1"/>
-          <p:nvPr/>
-        </p:nvSpPr>
-        <p:spPr>
-          <a:xfrm>
-            <a:off x="1024128" y="932688"/>
-            <a:ext cx="13533120" cy="411480"/>
-          </a:xfrm>
-          <a:prstGeom prst="rect">
-            <a:avLst/>
-          </a:prstGeom>
-          <a:noFill/>
-        </p:spPr>
-        <p:txBody>
-          <a:bodyPr wrap="square" lIns="0" tIns="0" rIns="0" bIns="0" anchor="t" rtlCol="0">
-            <a:noAutofit/>
-          </a:bodyPr>
-          <a:lstStyle/>
-          <a:p>
-            <a:pPr algn="l">
-              <a:spcBef>
-                <a:spcPts val="0"/>
-              </a:spcBef>
-              <a:spcAft>
-                <a:spcPts val="0"/>
-              </a:spcAft>
-              <a:buNone/>
-            </a:pPr>
-            <a:r>
-              <a:rPr lang="pt-BR" sz="1900">
-                <a:solidFill>
-                  <a:srgbClr val="3E721D"/>
-                </a:solidFill>
-                <a:latin typeface="Garet"/>
-                <a:ea typeface="Garet"/>
-                <a:cs typeface="Garet"/>
-                <a:sym typeface="Garet"/>
-              </a:rPr>
-              <a:t xml:space="preserve">Apresentado por  </a:t>
-            </a:r>
-            <a:r>
-              <a:rPr lang="pt-BR" sz="1900" b="1">
-                <a:solidFill>
-                  <a:srgbClr val="3E721D"/>
-                </a:solidFill>
-                <a:latin typeface="Garet Bold"/>
-                <a:ea typeface="Garet Bold"/>
-                <a:cs typeface="Garet Bold"/>
-                <a:sym typeface="Garet Bold"/>
-              </a:rPr>
-              <a:t>Matheus Rosa, Gabriely Paixão, Yvana Lopes, Milena Vitória e Myriam Caires</a:t>
-            </a:r>
-          </a:p>
-        </p:txBody>
-      </p:sp>
-      <p:sp>
-        <p:nvSpPr>
-          <p:cNvPr id="102" name="Ano 102"/>
+          <p:cNvPr id="101" name="Ano 101"/>
           <p:cNvSpPr txBox="1"/>
           <p:nvPr/>
         </p:nvSpPr>
@@ -6729,7 +6613,7 @@
       </p:sp>
       <p:sp>
         <p:nvSpPr>
-          <p:cNvPr id="103" name="Rodapé 103"/>
+          <p:cNvPr id="102" name="Rodapé 102"/>
           <p:cNvSpPr txBox="1"/>
           <p:nvPr/>
         </p:nvSpPr>
@@ -6775,7 +6659,7 @@
       </p:sp>
       <p:sp>
         <p:nvSpPr>
-          <p:cNvPr id="104" name="Página 104"/>
+          <p:cNvPr id="103" name="Página 103"/>
           <p:cNvSpPr txBox="1"/>
           <p:nvPr/>
         </p:nvSpPr>
@@ -6821,7 +6705,7 @@
       </p:sp>
       <p:sp>
         <p:nvSpPr>
-          <p:cNvPr id="105" name="Título 105"/>
+          <p:cNvPr id="104" name="Título 104"/>
           <p:cNvSpPr txBox="1"/>
           <p:nvPr/>
         </p:nvSpPr>
@@ -6896,7 +6780,7 @@
       </p:sp>
       <p:sp>
         <p:nvSpPr>
-          <p:cNvPr id="106" name="Texto 106"/>
+          <p:cNvPr id="105" name="Texto 105"/>
           <p:cNvSpPr txBox="1"/>
           <p:nvPr/>
         </p:nvSpPr>
@@ -6945,7 +6829,7 @@
       </p:sp>
       <p:grpSp>
         <p:nvGrpSpPr>
-          <p:cNvPr id="110" name="Item 110"/>
+          <p:cNvPr id="109" name="Item 109"/>
           <p:cNvGrpSpPr/>
           <p:nvPr/>
         </p:nvGrpSpPr>
@@ -6959,7 +6843,7 @@
         </p:grpSpPr>
         <p:sp>
           <p:nvSpPr>
-            <p:cNvPr id="107" name="Cartão 107"/>
+            <p:cNvPr id="106" name="Cartão 106"/>
             <p:cNvSpPr/>
             <p:nvPr/>
           </p:nvSpPr>
@@ -6991,7 +6875,7 @@
         </p:sp>
         <p:sp>
           <p:nvSpPr>
-            <p:cNvPr id="108" name="Texto 108"/>
+            <p:cNvPr id="107" name="Texto 107"/>
             <p:cNvSpPr txBox="1"/>
             <p:nvPr/>
           </p:nvSpPr>
@@ -7037,7 +6921,7 @@
         </p:sp>
         <p:sp>
           <p:nvSpPr>
-            <p:cNvPr id="109" name="Texto 109"/>
+            <p:cNvPr id="108" name="Texto 108"/>
             <p:cNvSpPr txBox="1"/>
             <p:nvPr/>
           </p:nvSpPr>
@@ -7099,7 +6983,7 @@
       </p:grpSp>
       <p:grpSp>
         <p:nvGrpSpPr>
-          <p:cNvPr id="114" name="Item 114"/>
+          <p:cNvPr id="113" name="Item 113"/>
           <p:cNvGrpSpPr/>
           <p:nvPr/>
         </p:nvGrpSpPr>
@@ -7113,7 +6997,7 @@
         </p:grpSpPr>
         <p:sp>
           <p:nvSpPr>
-            <p:cNvPr id="111" name="Cartão 111"/>
+            <p:cNvPr id="110" name="Cartão 110"/>
             <p:cNvSpPr/>
             <p:nvPr/>
           </p:nvSpPr>
@@ -7145,7 +7029,7 @@
         </p:sp>
         <p:sp>
           <p:nvSpPr>
-            <p:cNvPr id="112" name="Texto 112"/>
+            <p:cNvPr id="111" name="Texto 111"/>
             <p:cNvSpPr txBox="1"/>
             <p:nvPr/>
           </p:nvSpPr>
@@ -7191,7 +7075,7 @@
         </p:sp>
         <p:sp>
           <p:nvSpPr>
-            <p:cNvPr id="113" name="Texto 113"/>
+            <p:cNvPr id="112" name="Texto 112"/>
             <p:cNvSpPr txBox="1"/>
             <p:nvPr/>
           </p:nvSpPr>
@@ -7253,7 +7137,7 @@
       </p:grpSp>
       <p:grpSp>
         <p:nvGrpSpPr>
-          <p:cNvPr id="118" name="Item 118"/>
+          <p:cNvPr id="117" name="Item 117"/>
           <p:cNvGrpSpPr/>
           <p:nvPr/>
         </p:nvGrpSpPr>
@@ -7267,7 +7151,7 @@
         </p:grpSpPr>
         <p:sp>
           <p:nvSpPr>
-            <p:cNvPr id="115" name="Cartão 115"/>
+            <p:cNvPr id="114" name="Cartão 114"/>
             <p:cNvSpPr/>
             <p:nvPr/>
           </p:nvSpPr>
@@ -7299,7 +7183,7 @@
         </p:sp>
         <p:sp>
           <p:nvSpPr>
-            <p:cNvPr id="116" name="Texto 116"/>
+            <p:cNvPr id="115" name="Texto 115"/>
             <p:cNvSpPr txBox="1"/>
             <p:nvPr/>
           </p:nvSpPr>
@@ -7345,7 +7229,7 @@
         </p:sp>
         <p:sp>
           <p:nvSpPr>
-            <p:cNvPr id="117" name="Texto 117"/>
+            <p:cNvPr id="116" name="Texto 116"/>
             <p:cNvSpPr txBox="1"/>
             <p:nvPr/>
           </p:nvSpPr>
@@ -7407,7 +7291,7 @@
       </p:grpSp>
       <p:grpSp>
         <p:nvGrpSpPr>
-          <p:cNvPr id="122" name="Item 122"/>
+          <p:cNvPr id="121" name="Item 121"/>
           <p:cNvGrpSpPr/>
           <p:nvPr/>
         </p:nvGrpSpPr>
@@ -7421,7 +7305,7 @@
         </p:grpSpPr>
         <p:sp>
           <p:nvSpPr>
-            <p:cNvPr id="119" name="Cartão 119"/>
+            <p:cNvPr id="118" name="Cartão 118"/>
             <p:cNvSpPr/>
             <p:nvPr/>
           </p:nvSpPr>
@@ -7453,7 +7337,7 @@
         </p:sp>
         <p:sp>
           <p:nvSpPr>
-            <p:cNvPr id="120" name="Texto 120"/>
+            <p:cNvPr id="119" name="Texto 119"/>
             <p:cNvSpPr txBox="1"/>
             <p:nvPr/>
           </p:nvSpPr>
@@ -7499,7 +7383,7 @@
         </p:sp>
         <p:sp>
           <p:nvSpPr>
-            <p:cNvPr id="121" name="Texto 121"/>
+            <p:cNvPr id="120" name="Texto 120"/>
             <p:cNvSpPr txBox="1"/>
             <p:nvPr/>
           </p:nvSpPr>
@@ -7604,7 +7488,7 @@
                                           </p:stCondLst>
                                         </p:cTn>
                                         <p:tgtEl>
-                                          <p:spTgt spid="105"/>
+                                          <p:spTgt spid="104"/>
                                         </p:tgtEl>
                                         <p:attrNameLst>
                                           <p:attrName>style.visibility</p:attrName>
@@ -7618,7 +7502,7 @@
                                       <p:cBhvr>
                                         <p:cTn id="7" dur="700"/>
                                         <p:tgtEl>
-                                          <p:spTgt spid="105"/>
+                                          <p:spTgt spid="104"/>
                                         </p:tgtEl>
                                       </p:cBhvr>
                                     </p:animEffect>
@@ -7639,7 +7523,7 @@
                                           </p:stCondLst>
                                         </p:cTn>
                                         <p:tgtEl>
-                                          <p:spTgt spid="106"/>
+                                          <p:spTgt spid="105"/>
                                         </p:tgtEl>
                                         <p:attrNameLst>
                                           <p:attrName>style.visibility</p:attrName>
@@ -7653,7 +7537,7 @@
                                       <p:cBhvr>
                                         <p:cTn id="10" dur="700"/>
                                         <p:tgtEl>
-                                          <p:spTgt spid="106"/>
+                                          <p:spTgt spid="105"/>
                                         </p:tgtEl>
                                       </p:cBhvr>
                                     </p:animEffect>
@@ -7674,7 +7558,7 @@
                                           </p:stCondLst>
                                         </p:cTn>
                                         <p:tgtEl>
-                                          <p:spTgt spid="110"/>
+                                          <p:spTgt spid="109"/>
                                         </p:tgtEl>
                                         <p:attrNameLst>
                                           <p:attrName>style.visibility</p:attrName>
@@ -7688,7 +7572,7 @@
                                       <p:cBhvr>
                                         <p:cTn id="13" dur="700"/>
                                         <p:tgtEl>
-                                          <p:spTgt spid="110"/>
+                                          <p:spTgt spid="109"/>
                                         </p:tgtEl>
                                       </p:cBhvr>
                                     </p:animEffect>
@@ -7709,7 +7593,7 @@
                                           </p:stCondLst>
                                         </p:cTn>
                                         <p:tgtEl>
-                                          <p:spTgt spid="114"/>
+                                          <p:spTgt spid="113"/>
                                         </p:tgtEl>
                                         <p:attrNameLst>
                                           <p:attrName>style.visibility</p:attrName>
@@ -7723,7 +7607,7 @@
                                       <p:cBhvr>
                                         <p:cTn id="16" dur="700"/>
                                         <p:tgtEl>
-                                          <p:spTgt spid="114"/>
+                                          <p:spTgt spid="113"/>
                                         </p:tgtEl>
                                       </p:cBhvr>
                                     </p:animEffect>
@@ -7744,7 +7628,7 @@
                                           </p:stCondLst>
                                         </p:cTn>
                                         <p:tgtEl>
-                                          <p:spTgt spid="118"/>
+                                          <p:spTgt spid="117"/>
                                         </p:tgtEl>
                                         <p:attrNameLst>
                                           <p:attrName>style.visibility</p:attrName>
@@ -7758,7 +7642,7 @@
                                       <p:cBhvr>
                                         <p:cTn id="19" dur="700"/>
                                         <p:tgtEl>
-                                          <p:spTgt spid="118"/>
+                                          <p:spTgt spid="117"/>
                                         </p:tgtEl>
                                       </p:cBhvr>
                                     </p:animEffect>
@@ -7779,7 +7663,7 @@
                                           </p:stCondLst>
                                         </p:cTn>
                                         <p:tgtEl>
-                                          <p:spTgt spid="122"/>
+                                          <p:spTgt spid="121"/>
                                         </p:tgtEl>
                                         <p:attrNameLst>
                                           <p:attrName>style.visibility</p:attrName>
@@ -7793,7 +7677,7 @@
                                       <p:cBhvr>
                                         <p:cTn id="22" dur="700"/>
                                         <p:tgtEl>
-                                          <p:spTgt spid="122"/>
+                                          <p:spTgt spid="121"/>
                                         </p:tgtEl>
                                       </p:cBhvr>
                                     </p:animEffect>
@@ -7828,8 +7712,8 @@
       </p:par>
     </p:tnLst>
     <p:bldLst>
+      <p:bldP spid="104" grpId="0"/>
       <p:bldP spid="105" grpId="0"/>
-      <p:bldP spid="106" grpId="0"/>
     </p:bldLst>
   </p:timing>
 </p:sld>
@@ -8499,65 +8383,7 @@
       </p:grpSp>
       <p:sp>
         <p:nvSpPr>
-          <p:cNvPr id="101" name="Cabeçalho 101"/>
-          <p:cNvSpPr txBox="1"/>
-          <p:nvPr/>
-        </p:nvSpPr>
-        <p:spPr>
-          <a:xfrm>
-            <a:off x="1024128" y="932688"/>
-            <a:ext cx="13533120" cy="411480"/>
-          </a:xfrm>
-          <a:prstGeom prst="rect">
-            <a:avLst/>
-          </a:prstGeom>
-          <a:noFill/>
-        </p:spPr>
-        <p:txBody>
-          <a:bodyPr wrap="square" lIns="0" tIns="0" rIns="0" bIns="0" anchor="t" rtlCol="0">
-            <a:noAutofit/>
-          </a:bodyPr>
-          <a:lstStyle/>
-          <a:p>
-            <a:pPr algn="l">
-              <a:spcBef>
-                <a:spcPts val="0"/>
-              </a:spcBef>
-              <a:spcAft>
-                <a:spcPts val="0"/>
-              </a:spcAft>
-              <a:buNone/>
-            </a:pPr>
-            <a:r>
-              <a:rPr lang="pt-BR" sz="1900">
-                <a:solidFill>
-                  <a:srgbClr val="3E721D"/>
-                </a:solidFill>
-                <a:latin typeface="Garet"/>
-                <a:ea typeface="Garet"/>
-                <a:cs typeface="Garet"/>
-                <a:sym typeface="Garet"/>
-              </a:rPr>
-              <a:t xml:space="preserve">Apresentado por  </a:t>
-            </a:r>
-            <a:r>
-              <a:rPr lang="pt-BR" sz="1900" b="1">
-                <a:solidFill>
-                  <a:srgbClr val="3E721D"/>
-                </a:solidFill>
-                <a:latin typeface="Garet Bold"/>
-                <a:ea typeface="Garet Bold"/>
-                <a:cs typeface="Garet Bold"/>
-                <a:sym typeface="Garet Bold"/>
-              </a:rPr>
-              <a:t>Matheus Rosa, Gabriely Paixão, Yvana Lopes, Milena Vitória e Myriam Caires</a:t>
-            </a:r>
-          </a:p>
-        </p:txBody>
-      </p:sp>
-      <p:sp>
-        <p:nvSpPr>
-          <p:cNvPr id="102" name="Ano 102"/>
+          <p:cNvPr id="101" name="Ano 101"/>
           <p:cNvSpPr txBox="1"/>
           <p:nvPr/>
         </p:nvSpPr>
@@ -8603,7 +8429,7 @@
       </p:sp>
       <p:sp>
         <p:nvSpPr>
-          <p:cNvPr id="103" name="Rodapé 103"/>
+          <p:cNvPr id="102" name="Rodapé 102"/>
           <p:cNvSpPr txBox="1"/>
           <p:nvPr/>
         </p:nvSpPr>
@@ -8649,7 +8475,7 @@
       </p:sp>
       <p:sp>
         <p:nvSpPr>
-          <p:cNvPr id="104" name="Página 104"/>
+          <p:cNvPr id="103" name="Página 103"/>
           <p:cNvSpPr txBox="1"/>
           <p:nvPr/>
         </p:nvSpPr>
@@ -8695,7 +8521,7 @@
       </p:sp>
       <p:sp>
         <p:nvSpPr>
-          <p:cNvPr id="105" name="Título 105"/>
+          <p:cNvPr id="104" name="Título 104"/>
           <p:cNvSpPr txBox="1"/>
           <p:nvPr/>
         </p:nvSpPr>
@@ -8744,7 +8570,7 @@
       </p:sp>
       <p:grpSp>
         <p:nvGrpSpPr>
-          <p:cNvPr id="109" name="Cartão 109"/>
+          <p:cNvPr id="108" name="Cartão 108"/>
           <p:cNvGrpSpPr/>
           <p:nvPr/>
         </p:nvGrpSpPr>
@@ -8758,7 +8584,7 @@
         </p:grpSpPr>
         <p:sp>
           <p:nvSpPr>
-            <p:cNvPr id="106" name="Cartão 106"/>
+            <p:cNvPr id="105" name="Cartão 105"/>
             <p:cNvSpPr/>
             <p:nvPr/>
           </p:nvSpPr>
@@ -8790,7 +8616,7 @@
         </p:sp>
         <p:sp>
           <p:nvSpPr>
-            <p:cNvPr id="107" name="Texto 107"/>
+            <p:cNvPr id="106" name="Texto 106"/>
             <p:cNvSpPr txBox="1"/>
             <p:nvPr/>
           </p:nvSpPr>
@@ -8836,7 +8662,7 @@
         </p:sp>
         <p:sp>
           <p:nvSpPr>
-            <p:cNvPr id="108" name="Texto 108"/>
+            <p:cNvPr id="107" name="Texto 107"/>
             <p:cNvSpPr txBox="1"/>
             <p:nvPr/>
           </p:nvSpPr>
@@ -8912,7 +8738,7 @@
       </p:grpSp>
       <p:grpSp>
         <p:nvGrpSpPr>
-          <p:cNvPr id="113" name="Cartão 113"/>
+          <p:cNvPr id="112" name="Cartão 112"/>
           <p:cNvGrpSpPr/>
           <p:nvPr/>
         </p:nvGrpSpPr>
@@ -8926,7 +8752,7 @@
         </p:grpSpPr>
         <p:sp>
           <p:nvSpPr>
-            <p:cNvPr id="110" name="Cartão 110"/>
+            <p:cNvPr id="109" name="Cartão 109"/>
             <p:cNvSpPr/>
             <p:nvPr/>
           </p:nvSpPr>
@@ -8958,7 +8784,7 @@
         </p:sp>
         <p:sp>
           <p:nvSpPr>
-            <p:cNvPr id="111" name="Texto 111"/>
+            <p:cNvPr id="110" name="Texto 110"/>
             <p:cNvSpPr txBox="1"/>
             <p:nvPr/>
           </p:nvSpPr>
@@ -9004,7 +8830,7 @@
         </p:sp>
         <p:sp>
           <p:nvSpPr>
-            <p:cNvPr id="112" name="Texto 112"/>
+            <p:cNvPr id="111" name="Texto 111"/>
             <p:cNvSpPr txBox="1"/>
             <p:nvPr/>
           </p:nvSpPr>
@@ -9080,7 +8906,7 @@
       </p:grpSp>
       <p:grpSp>
         <p:nvGrpSpPr>
-          <p:cNvPr id="117" name="Cartão 117"/>
+          <p:cNvPr id="116" name="Cartão 116"/>
           <p:cNvGrpSpPr/>
           <p:nvPr/>
         </p:nvGrpSpPr>
@@ -9094,7 +8920,7 @@
         </p:grpSpPr>
         <p:sp>
           <p:nvSpPr>
-            <p:cNvPr id="114" name="Cartão 114"/>
+            <p:cNvPr id="113" name="Cartão 113"/>
             <p:cNvSpPr/>
             <p:nvPr/>
           </p:nvSpPr>
@@ -9126,7 +8952,7 @@
         </p:sp>
         <p:sp>
           <p:nvSpPr>
-            <p:cNvPr id="115" name="Texto 115"/>
+            <p:cNvPr id="114" name="Texto 114"/>
             <p:cNvSpPr txBox="1"/>
             <p:nvPr/>
           </p:nvSpPr>
@@ -9172,7 +8998,7 @@
         </p:sp>
         <p:sp>
           <p:nvSpPr>
-            <p:cNvPr id="116" name="Texto 116"/>
+            <p:cNvPr id="115" name="Texto 115"/>
             <p:cNvSpPr txBox="1"/>
             <p:nvPr/>
           </p:nvSpPr>
@@ -9291,7 +9117,7 @@
                                           </p:stCondLst>
                                         </p:cTn>
                                         <p:tgtEl>
-                                          <p:spTgt spid="105"/>
+                                          <p:spTgt spid="104"/>
                                         </p:tgtEl>
                                         <p:attrNameLst>
                                           <p:attrName>style.visibility</p:attrName>
@@ -9305,7 +9131,7 @@
                                       <p:cBhvr>
                                         <p:cTn id="7" dur="700"/>
                                         <p:tgtEl>
-                                          <p:spTgt spid="105"/>
+                                          <p:spTgt spid="104"/>
                                         </p:tgtEl>
                                       </p:cBhvr>
                                     </p:animEffect>
@@ -9326,7 +9152,7 @@
                                           </p:stCondLst>
                                         </p:cTn>
                                         <p:tgtEl>
-                                          <p:spTgt spid="109"/>
+                                          <p:spTgt spid="108"/>
                                         </p:tgtEl>
                                         <p:attrNameLst>
                                           <p:attrName>style.visibility</p:attrName>
@@ -9340,7 +9166,7 @@
                                       <p:cBhvr>
                                         <p:cTn id="10" dur="700"/>
                                         <p:tgtEl>
-                                          <p:spTgt spid="109"/>
+                                          <p:spTgt spid="108"/>
                                         </p:tgtEl>
                                       </p:cBhvr>
                                     </p:animEffect>
@@ -9361,7 +9187,7 @@
                                           </p:stCondLst>
                                         </p:cTn>
                                         <p:tgtEl>
-                                          <p:spTgt spid="113"/>
+                                          <p:spTgt spid="112"/>
                                         </p:tgtEl>
                                         <p:attrNameLst>
                                           <p:attrName>style.visibility</p:attrName>
@@ -9375,7 +9201,7 @@
                                       <p:cBhvr>
                                         <p:cTn id="13" dur="700"/>
                                         <p:tgtEl>
-                                          <p:spTgt spid="113"/>
+                                          <p:spTgt spid="112"/>
                                         </p:tgtEl>
                                       </p:cBhvr>
                                     </p:animEffect>
@@ -9396,7 +9222,7 @@
                                           </p:stCondLst>
                                         </p:cTn>
                                         <p:tgtEl>
-                                          <p:spTgt spid="117"/>
+                                          <p:spTgt spid="116"/>
                                         </p:tgtEl>
                                         <p:attrNameLst>
                                           <p:attrName>style.visibility</p:attrName>
@@ -9410,7 +9236,7 @@
                                       <p:cBhvr>
                                         <p:cTn id="16" dur="700"/>
                                         <p:tgtEl>
-                                          <p:spTgt spid="117"/>
+                                          <p:spTgt spid="116"/>
                                         </p:tgtEl>
                                       </p:cBhvr>
                                     </p:animEffect>
@@ -9445,7 +9271,7 @@
       </p:par>
     </p:tnLst>
     <p:bldLst>
-      <p:bldP spid="105" grpId="0"/>
+      <p:bldP spid="104" grpId="0"/>
     </p:bldLst>
   </p:timing>
 </p:sld>
@@ -10115,65 +9941,7 @@
       </p:grpSp>
       <p:sp>
         <p:nvSpPr>
-          <p:cNvPr id="101" name="Cabeçalho 101"/>
-          <p:cNvSpPr txBox="1"/>
-          <p:nvPr/>
-        </p:nvSpPr>
-        <p:spPr>
-          <a:xfrm>
-            <a:off x="1024128" y="932688"/>
-            <a:ext cx="13533120" cy="411480"/>
-          </a:xfrm>
-          <a:prstGeom prst="rect">
-            <a:avLst/>
-          </a:prstGeom>
-          <a:noFill/>
-        </p:spPr>
-        <p:txBody>
-          <a:bodyPr wrap="square" lIns="0" tIns="0" rIns="0" bIns="0" anchor="t" rtlCol="0">
-            <a:noAutofit/>
-          </a:bodyPr>
-          <a:lstStyle/>
-          <a:p>
-            <a:pPr algn="l">
-              <a:spcBef>
-                <a:spcPts val="0"/>
-              </a:spcBef>
-              <a:spcAft>
-                <a:spcPts val="0"/>
-              </a:spcAft>
-              <a:buNone/>
-            </a:pPr>
-            <a:r>
-              <a:rPr lang="pt-BR" sz="1900">
-                <a:solidFill>
-                  <a:srgbClr val="3E721D"/>
-                </a:solidFill>
-                <a:latin typeface="Garet"/>
-                <a:ea typeface="Garet"/>
-                <a:cs typeface="Garet"/>
-                <a:sym typeface="Garet"/>
-              </a:rPr>
-              <a:t xml:space="preserve">Apresentado por  </a:t>
-            </a:r>
-            <a:r>
-              <a:rPr lang="pt-BR" sz="1900" b="1">
-                <a:solidFill>
-                  <a:srgbClr val="3E721D"/>
-                </a:solidFill>
-                <a:latin typeface="Garet Bold"/>
-                <a:ea typeface="Garet Bold"/>
-                <a:cs typeface="Garet Bold"/>
-                <a:sym typeface="Garet Bold"/>
-              </a:rPr>
-              <a:t>Matheus Rosa, Gabriely Paixão, Yvana Lopes, Milena Vitória e Myriam Caires</a:t>
-            </a:r>
-          </a:p>
-        </p:txBody>
-      </p:sp>
-      <p:sp>
-        <p:nvSpPr>
-          <p:cNvPr id="102" name="Ano 102"/>
+          <p:cNvPr id="101" name="Ano 101"/>
           <p:cNvSpPr txBox="1"/>
           <p:nvPr/>
         </p:nvSpPr>
@@ -10219,7 +9987,7 @@
       </p:sp>
       <p:sp>
         <p:nvSpPr>
-          <p:cNvPr id="103" name="Rodapé 103"/>
+          <p:cNvPr id="102" name="Rodapé 102"/>
           <p:cNvSpPr txBox="1"/>
           <p:nvPr/>
         </p:nvSpPr>
@@ -10265,7 +10033,7 @@
       </p:sp>
       <p:sp>
         <p:nvSpPr>
-          <p:cNvPr id="104" name="Página 104"/>
+          <p:cNvPr id="103" name="Página 103"/>
           <p:cNvSpPr txBox="1"/>
           <p:nvPr/>
         </p:nvSpPr>
@@ -10311,7 +10079,7 @@
       </p:sp>
       <p:sp>
         <p:nvSpPr>
-          <p:cNvPr id="105" name="Título 105"/>
+          <p:cNvPr id="104" name="Título 104"/>
           <p:cNvSpPr txBox="1"/>
           <p:nvPr/>
         </p:nvSpPr>
@@ -10360,7 +10128,7 @@
       </p:sp>
       <p:sp>
         <p:nvSpPr>
-          <p:cNvPr id="106" name="Texto 106"/>
+          <p:cNvPr id="105" name="Texto 105"/>
           <p:cNvSpPr txBox="1"/>
           <p:nvPr/>
         </p:nvSpPr>
@@ -10433,7 +10201,7 @@
       </p:sp>
       <p:grpSp>
         <p:nvGrpSpPr>
-          <p:cNvPr id="113" name="Destaques 113"/>
+          <p:cNvPr id="112" name="Destaques 112"/>
           <p:cNvGrpSpPr/>
           <p:nvPr/>
         </p:nvGrpSpPr>
@@ -10447,7 +10215,7 @@
         </p:grpSpPr>
         <p:sp>
           <p:nvSpPr>
-            <p:cNvPr id="107" name="Cartão 107"/>
+            <p:cNvPr id="106" name="Cartão 106"/>
             <p:cNvSpPr/>
             <p:nvPr/>
           </p:nvSpPr>
@@ -10479,7 +10247,7 @@
         </p:sp>
         <p:sp>
           <p:nvSpPr>
-            <p:cNvPr id="108" name="Texto 108"/>
+            <p:cNvPr id="107" name="Texto 107"/>
             <p:cNvSpPr txBox="1"/>
             <p:nvPr/>
           </p:nvSpPr>
@@ -10525,7 +10293,7 @@
         </p:sp>
         <p:sp>
           <p:nvSpPr>
-            <p:cNvPr id="109" name="Cartão 109"/>
+            <p:cNvPr id="108" name="Cartão 108"/>
             <p:cNvSpPr/>
             <p:nvPr/>
           </p:nvSpPr>
@@ -10557,7 +10325,7 @@
         </p:sp>
         <p:sp>
           <p:nvSpPr>
-            <p:cNvPr id="110" name="Texto 110"/>
+            <p:cNvPr id="109" name="Texto 109"/>
             <p:cNvSpPr txBox="1"/>
             <p:nvPr/>
           </p:nvSpPr>
@@ -10603,7 +10371,7 @@
         </p:sp>
         <p:sp>
           <p:nvSpPr>
-            <p:cNvPr id="111" name="Cartão 111"/>
+            <p:cNvPr id="110" name="Cartão 110"/>
             <p:cNvSpPr/>
             <p:nvPr/>
           </p:nvSpPr>
@@ -10635,7 +10403,7 @@
         </p:sp>
         <p:sp>
           <p:nvSpPr>
-            <p:cNvPr id="112" name="Texto 112"/>
+            <p:cNvPr id="111" name="Texto 111"/>
             <p:cNvSpPr txBox="1"/>
             <p:nvPr/>
           </p:nvSpPr>
@@ -10725,7 +10493,7 @@
                                           </p:stCondLst>
                                         </p:cTn>
                                         <p:tgtEl>
-                                          <p:spTgt spid="105"/>
+                                          <p:spTgt spid="104"/>
                                         </p:tgtEl>
                                         <p:attrNameLst>
                                           <p:attrName>style.visibility</p:attrName>
@@ -10739,7 +10507,7 @@
                                       <p:cBhvr>
                                         <p:cTn id="7" dur="700"/>
                                         <p:tgtEl>
-                                          <p:spTgt spid="105"/>
+                                          <p:spTgt spid="104"/>
                                         </p:tgtEl>
                                       </p:cBhvr>
                                     </p:animEffect>
@@ -10760,7 +10528,7 @@
                                           </p:stCondLst>
                                         </p:cTn>
                                         <p:tgtEl>
-                                          <p:spTgt spid="106"/>
+                                          <p:spTgt spid="105"/>
                                         </p:tgtEl>
                                         <p:attrNameLst>
                                           <p:attrName>style.visibility</p:attrName>
@@ -10774,7 +10542,7 @@
                                       <p:cBhvr>
                                         <p:cTn id="10" dur="700"/>
                                         <p:tgtEl>
-                                          <p:spTgt spid="106"/>
+                                          <p:spTgt spid="105"/>
                                         </p:tgtEl>
                                       </p:cBhvr>
                                     </p:animEffect>
@@ -10795,7 +10563,7 @@
                                           </p:stCondLst>
                                         </p:cTn>
                                         <p:tgtEl>
-                                          <p:spTgt spid="113"/>
+                                          <p:spTgt spid="112"/>
                                         </p:tgtEl>
                                         <p:attrNameLst>
                                           <p:attrName>style.visibility</p:attrName>
@@ -10809,7 +10577,7 @@
                                       <p:cBhvr>
                                         <p:cTn id="13" dur="700"/>
                                         <p:tgtEl>
-                                          <p:spTgt spid="113"/>
+                                          <p:spTgt spid="112"/>
                                         </p:tgtEl>
                                       </p:cBhvr>
                                     </p:animEffect>
@@ -10844,8 +10612,8 @@
       </p:par>
     </p:tnLst>
     <p:bldLst>
+      <p:bldP spid="104" grpId="0"/>
       <p:bldP spid="105" grpId="0"/>
-      <p:bldP spid="106" grpId="0"/>
     </p:bldLst>
   </p:timing>
 </p:sld>
@@ -11515,65 +11283,7 @@
       </p:grpSp>
       <p:sp>
         <p:nvSpPr>
-          <p:cNvPr id="101" name="Cabeçalho 101"/>
-          <p:cNvSpPr txBox="1"/>
-          <p:nvPr/>
-        </p:nvSpPr>
-        <p:spPr>
-          <a:xfrm>
-            <a:off x="1024128" y="932688"/>
-            <a:ext cx="13533120" cy="411480"/>
-          </a:xfrm>
-          <a:prstGeom prst="rect">
-            <a:avLst/>
-          </a:prstGeom>
-          <a:noFill/>
-        </p:spPr>
-        <p:txBody>
-          <a:bodyPr wrap="square" lIns="0" tIns="0" rIns="0" bIns="0" anchor="t" rtlCol="0">
-            <a:noAutofit/>
-          </a:bodyPr>
-          <a:lstStyle/>
-          <a:p>
-            <a:pPr algn="l">
-              <a:spcBef>
-                <a:spcPts val="0"/>
-              </a:spcBef>
-              <a:spcAft>
-                <a:spcPts val="0"/>
-              </a:spcAft>
-              <a:buNone/>
-            </a:pPr>
-            <a:r>
-              <a:rPr lang="pt-BR" sz="1900">
-                <a:solidFill>
-                  <a:srgbClr val="3E721D"/>
-                </a:solidFill>
-                <a:latin typeface="Garet"/>
-                <a:ea typeface="Garet"/>
-                <a:cs typeface="Garet"/>
-                <a:sym typeface="Garet"/>
-              </a:rPr>
-              <a:t xml:space="preserve">Apresentado por  </a:t>
-            </a:r>
-            <a:r>
-              <a:rPr lang="pt-BR" sz="1900" b="1">
-                <a:solidFill>
-                  <a:srgbClr val="3E721D"/>
-                </a:solidFill>
-                <a:latin typeface="Garet Bold"/>
-                <a:ea typeface="Garet Bold"/>
-                <a:cs typeface="Garet Bold"/>
-                <a:sym typeface="Garet Bold"/>
-              </a:rPr>
-              <a:t>Matheus Rosa, Gabriely Paixão, Yvana Lopes, Milena Vitória e Myriam Caires</a:t>
-            </a:r>
-          </a:p>
-        </p:txBody>
-      </p:sp>
-      <p:sp>
-        <p:nvSpPr>
-          <p:cNvPr id="102" name="Ano 102"/>
+          <p:cNvPr id="101" name="Ano 101"/>
           <p:cNvSpPr txBox="1"/>
           <p:nvPr/>
         </p:nvSpPr>
@@ -11619,7 +11329,7 @@
       </p:sp>
       <p:sp>
         <p:nvSpPr>
-          <p:cNvPr id="103" name="Rodapé 103"/>
+          <p:cNvPr id="102" name="Rodapé 102"/>
           <p:cNvSpPr txBox="1"/>
           <p:nvPr/>
         </p:nvSpPr>
@@ -11665,7 +11375,7 @@
       </p:sp>
       <p:sp>
         <p:nvSpPr>
-          <p:cNvPr id="104" name="Página 104"/>
+          <p:cNvPr id="103" name="Página 103"/>
           <p:cNvSpPr txBox="1"/>
           <p:nvPr/>
         </p:nvSpPr>
@@ -11711,7 +11421,7 @@
       </p:sp>
       <p:sp>
         <p:nvSpPr>
-          <p:cNvPr id="105" name="Título 105"/>
+          <p:cNvPr id="104" name="Título 104"/>
           <p:cNvSpPr txBox="1"/>
           <p:nvPr/>
         </p:nvSpPr>
@@ -11760,7 +11470,7 @@
       </p:sp>
       <p:grpSp>
         <p:nvGrpSpPr>
-          <p:cNvPr id="108" name="Referências 108"/>
+          <p:cNvPr id="107" name="Referências 107"/>
           <p:cNvGrpSpPr/>
           <p:nvPr/>
         </p:nvGrpSpPr>
@@ -11774,7 +11484,7 @@
         </p:grpSpPr>
         <p:sp>
           <p:nvSpPr>
-            <p:cNvPr id="106" name="Cartão 106"/>
+            <p:cNvPr id="105" name="Cartão 105"/>
             <p:cNvSpPr/>
             <p:nvPr/>
           </p:nvSpPr>
@@ -11806,7 +11516,7 @@
         </p:sp>
         <p:sp>
           <p:nvSpPr>
-            <p:cNvPr id="107" name="Texto 107"/>
+            <p:cNvPr id="106" name="Texto 106"/>
             <p:cNvSpPr txBox="1"/>
             <p:nvPr/>
           </p:nvSpPr>
@@ -12245,7 +11955,7 @@
                                           </p:stCondLst>
                                         </p:cTn>
                                         <p:tgtEl>
-                                          <p:spTgt spid="105"/>
+                                          <p:spTgt spid="104"/>
                                         </p:tgtEl>
                                         <p:attrNameLst>
                                           <p:attrName>style.visibility</p:attrName>
@@ -12259,7 +11969,7 @@
                                       <p:cBhvr>
                                         <p:cTn id="7" dur="700"/>
                                         <p:tgtEl>
-                                          <p:spTgt spid="105"/>
+                                          <p:spTgt spid="104"/>
                                         </p:tgtEl>
                                       </p:cBhvr>
                                     </p:animEffect>
@@ -12280,7 +11990,7 @@
                                           </p:stCondLst>
                                         </p:cTn>
                                         <p:tgtEl>
-                                          <p:spTgt spid="108"/>
+                                          <p:spTgt spid="107"/>
                                         </p:tgtEl>
                                         <p:attrNameLst>
                                           <p:attrName>style.visibility</p:attrName>
@@ -12294,7 +12004,7 @@
                                       <p:cBhvr>
                                         <p:cTn id="10" dur="700"/>
                                         <p:tgtEl>
-                                          <p:spTgt spid="108"/>
+                                          <p:spTgt spid="107"/>
                                         </p:tgtEl>
                                       </p:cBhvr>
                                     </p:animEffect>
@@ -12329,7 +12039,7 @@
       </p:par>
     </p:tnLst>
     <p:bldLst>
-      <p:bldP spid="105" grpId="0"/>
+      <p:bldP spid="104" grpId="0"/>
     </p:bldLst>
   </p:timing>
 </p:sld>
@@ -13014,9 +12724,9 @@
         </p:nvGrpSpPr>
         <p:grpSpPr>
           <a:xfrm>
-            <a:off x="7040880" y="2606040"/>
+            <a:off x="7040880" y="3063240"/>
             <a:ext cx="4206240" cy="658368"/>
-            <a:chOff x="7040880" y="2606040"/>
+            <a:chOff x="7040880" y="3063240"/>
             <a:chExt cx="4206240" cy="658368"/>
           </a:xfrm>
         </p:grpSpPr>
@@ -13028,7 +12738,7 @@
           </p:nvSpPr>
           <p:spPr>
             <a:xfrm>
-              <a:off x="7040880" y="2606040"/>
+              <a:off x="7040880" y="3063240"/>
               <a:ext cx="4206240" cy="658368"/>
             </a:xfrm>
             <a:prstGeom prst="roundRect">
@@ -13062,7 +12772,7 @@
           </p:nvSpPr>
           <p:spPr>
             <a:xfrm>
-              <a:off x="7040880" y="2606040"/>
+              <a:off x="7040880" y="3063240"/>
               <a:ext cx="4206240" cy="658368"/>
             </a:xfrm>
             <a:prstGeom prst="rect">
@@ -13109,7 +12819,7 @@
         </p:nvSpPr>
         <p:spPr>
           <a:xfrm>
-            <a:off x="2194560" y="3383280"/>
+            <a:off x="2194560" y="3840480"/>
             <a:ext cx="13898880" cy="2011680"/>
           </a:xfrm>
           <a:prstGeom prst="rect">
@@ -13158,7 +12868,7 @@
         </p:nvSpPr>
         <p:spPr>
           <a:xfrm>
-            <a:off x="3108960" y="5486400"/>
+            <a:off x="3108960" y="5943600"/>
             <a:ext cx="12070080" cy="548640"/>
           </a:xfrm>
           <a:prstGeom prst="rect">
@@ -13196,113 +12906,6 @@
           </a:p>
         </p:txBody>
       </p:sp>
-      <p:grpSp>
-        <p:nvGrpSpPr>
-          <p:cNvPr id="108" name="Integrantes 108"/>
-          <p:cNvGrpSpPr/>
-          <p:nvPr/>
-        </p:nvGrpSpPr>
-        <p:grpSpPr>
-          <a:xfrm>
-            <a:off x="2194560" y="6446520"/>
-            <a:ext cx="13898880" cy="868680"/>
-            <a:chOff x="2194560" y="6446520"/>
-            <a:chExt cx="13898880" cy="868680"/>
-          </a:xfrm>
-        </p:grpSpPr>
-        <p:sp>
-          <p:nvSpPr>
-            <p:cNvPr id="106" name="Texto 106"/>
-            <p:cNvSpPr txBox="1"/>
-            <p:nvPr/>
-          </p:nvSpPr>
-          <p:spPr>
-            <a:xfrm>
-              <a:off x="2743200" y="6446520"/>
-              <a:ext cx="12801600" cy="365760"/>
-            </a:xfrm>
-            <a:prstGeom prst="rect">
-              <a:avLst/>
-            </a:prstGeom>
-            <a:noFill/>
-          </p:spPr>
-          <p:txBody>
-            <a:bodyPr wrap="square" lIns="0" tIns="0" rIns="0" bIns="0" anchor="t" rtlCol="0">
-              <a:noAutofit/>
-            </a:bodyPr>
-            <a:lstStyle/>
-            <a:p>
-              <a:pPr algn="ctr">
-                <a:spcBef>
-                  <a:spcPts val="0"/>
-                </a:spcBef>
-                <a:spcAft>
-                  <a:spcPts val="0"/>
-                </a:spcAft>
-                <a:buNone/>
-              </a:pPr>
-              <a:r>
-                <a:rPr lang="pt-BR" sz="1600" spc="360">
-                  <a:solidFill>
-                    <a:srgbClr val="3E721D"/>
-                  </a:solidFill>
-                  <a:latin typeface="Garet"/>
-                  <a:ea typeface="Garet"/>
-                  <a:cs typeface="Garet"/>
-                  <a:sym typeface="Garet"/>
-                </a:rPr>
-                <a:t>APRESENTADO POR</a:t>
-              </a:r>
-            </a:p>
-          </p:txBody>
-        </p:sp>
-        <p:sp>
-          <p:nvSpPr>
-            <p:cNvPr id="107" name="Texto 107"/>
-            <p:cNvSpPr txBox="1"/>
-            <p:nvPr/>
-          </p:nvSpPr>
-          <p:spPr>
-            <a:xfrm>
-              <a:off x="2194560" y="6858000"/>
-              <a:ext cx="13898880" cy="457200"/>
-            </a:xfrm>
-            <a:prstGeom prst="rect">
-              <a:avLst/>
-            </a:prstGeom>
-            <a:noFill/>
-          </p:spPr>
-          <p:txBody>
-            <a:bodyPr wrap="square" lIns="0" tIns="0" rIns="0" bIns="0" anchor="t" rtlCol="0">
-              <a:noAutofit/>
-            </a:bodyPr>
-            <a:lstStyle/>
-            <a:p>
-              <a:pPr algn="ctr">
-                <a:spcBef>
-                  <a:spcPts val="0"/>
-                </a:spcBef>
-                <a:spcAft>
-                  <a:spcPts val="0"/>
-                </a:spcAft>
-                <a:buNone/>
-              </a:pPr>
-              <a:r>
-                <a:rPr lang="pt-BR" sz="2100" b="1">
-                  <a:solidFill>
-                    <a:srgbClr val="3E721D"/>
-                  </a:solidFill>
-                  <a:latin typeface="Garet Bold"/>
-                  <a:ea typeface="Garet Bold"/>
-                  <a:cs typeface="Garet Bold"/>
-                  <a:sym typeface="Garet Bold"/>
-                </a:rPr>
-                <a:t>Matheus Rosa  •  Gabriely Paixão  •  Yvana Lopes  •  Milena Vitória  •  Myriam Caires</a:t>
-              </a:r>
-            </a:p>
-          </p:txBody>
-        </p:sp>
-      </p:grpSp>
     </p:spTree>
   </p:cSld>
   <p:clrMapOvr>
@@ -13439,41 +13042,6 @@
                                   </p:childTnLst>
                                 </p:cTn>
                               </p:par>
-                              <p:par>
-                                <p:cTn id="14" presetID="10" presetClass="entr" presetSubtype="0" fill="hold" grpId="0" nodeType="withEffect">
-                                  <p:stCondLst>
-                                    <p:cond delay="550"/>
-                                  </p:stCondLst>
-                                  <p:childTnLst>
-                                    <p:set>
-                                      <p:cBhvr>
-                                        <p:cTn id="15" dur="1" fill="hold">
-                                          <p:stCondLst>
-                                            <p:cond delay="0"/>
-                                          </p:stCondLst>
-                                        </p:cTn>
-                                        <p:tgtEl>
-                                          <p:spTgt spid="108"/>
-                                        </p:tgtEl>
-                                        <p:attrNameLst>
-                                          <p:attrName>style.visibility</p:attrName>
-                                        </p:attrNameLst>
-                                      </p:cBhvr>
-                                      <p:to>
-                                        <p:strVal val="visible"/>
-                                      </p:to>
-                                    </p:set>
-                                    <p:animEffect transition="in" filter="fade">
-                                      <p:cBhvr>
-                                        <p:cTn id="16" dur="700"/>
-                                        <p:tgtEl>
-                                          <p:spTgt spid="108"/>
-                                        </p:tgtEl>
-                                      </p:cBhvr>
-                                    </p:animEffect>
-                                  </p:childTnLst>
-                                </p:cTn>
-                              </p:par>
                             </p:childTnLst>
                           </p:cTn>
                         </p:par>
@@ -14173,65 +13741,7 @@
       </p:grpSp>
       <p:sp>
         <p:nvSpPr>
-          <p:cNvPr id="101" name="Cabeçalho 101"/>
-          <p:cNvSpPr txBox="1"/>
-          <p:nvPr/>
-        </p:nvSpPr>
-        <p:spPr>
-          <a:xfrm>
-            <a:off x="1024128" y="932688"/>
-            <a:ext cx="13533120" cy="411480"/>
-          </a:xfrm>
-          <a:prstGeom prst="rect">
-            <a:avLst/>
-          </a:prstGeom>
-          <a:noFill/>
-        </p:spPr>
-        <p:txBody>
-          <a:bodyPr wrap="square" lIns="0" tIns="0" rIns="0" bIns="0" anchor="t" rtlCol="0">
-            <a:noAutofit/>
-          </a:bodyPr>
-          <a:lstStyle/>
-          <a:p>
-            <a:pPr algn="l">
-              <a:spcBef>
-                <a:spcPts val="0"/>
-              </a:spcBef>
-              <a:spcAft>
-                <a:spcPts val="0"/>
-              </a:spcAft>
-              <a:buNone/>
-            </a:pPr>
-            <a:r>
-              <a:rPr lang="pt-BR" sz="1900">
-                <a:solidFill>
-                  <a:srgbClr val="3E721D"/>
-                </a:solidFill>
-                <a:latin typeface="Garet"/>
-                <a:ea typeface="Garet"/>
-                <a:cs typeface="Garet"/>
-                <a:sym typeface="Garet"/>
-              </a:rPr>
-              <a:t xml:space="preserve">Apresentado por  </a:t>
-            </a:r>
-            <a:r>
-              <a:rPr lang="pt-BR" sz="1900" b="1">
-                <a:solidFill>
-                  <a:srgbClr val="3E721D"/>
-                </a:solidFill>
-                <a:latin typeface="Garet Bold"/>
-                <a:ea typeface="Garet Bold"/>
-                <a:cs typeface="Garet Bold"/>
-                <a:sym typeface="Garet Bold"/>
-              </a:rPr>
-              <a:t>Matheus Rosa, Gabriely Paixão, Yvana Lopes, Milena Vitória e Myriam Caires</a:t>
-            </a:r>
-          </a:p>
-        </p:txBody>
-      </p:sp>
-      <p:sp>
-        <p:nvSpPr>
-          <p:cNvPr id="102" name="Ano 102"/>
+          <p:cNvPr id="101" name="Ano 101"/>
           <p:cNvSpPr txBox="1"/>
           <p:nvPr/>
         </p:nvSpPr>
@@ -14277,7 +13787,7 @@
       </p:sp>
       <p:sp>
         <p:nvSpPr>
-          <p:cNvPr id="103" name="Rodapé 103"/>
+          <p:cNvPr id="102" name="Rodapé 102"/>
           <p:cNvSpPr txBox="1"/>
           <p:nvPr/>
         </p:nvSpPr>
@@ -14323,7 +13833,7 @@
       </p:sp>
       <p:sp>
         <p:nvSpPr>
-          <p:cNvPr id="104" name="Página 104"/>
+          <p:cNvPr id="103" name="Página 103"/>
           <p:cNvSpPr txBox="1"/>
           <p:nvPr/>
         </p:nvSpPr>
@@ -14369,7 +13879,7 @@
       </p:sp>
       <p:sp>
         <p:nvSpPr>
-          <p:cNvPr id="105" name="Título 105"/>
+          <p:cNvPr id="104" name="Título 104"/>
           <p:cNvSpPr txBox="1"/>
           <p:nvPr/>
         </p:nvSpPr>
@@ -14418,7 +13928,7 @@
       </p:sp>
       <p:sp>
         <p:nvSpPr>
-          <p:cNvPr id="106" name="Texto 106"/>
+          <p:cNvPr id="105" name="Texto 105"/>
           <p:cNvSpPr txBox="1"/>
           <p:nvPr/>
         </p:nvSpPr>
@@ -14479,7 +13989,7 @@
       </p:sp>
       <p:grpSp>
         <p:nvGrpSpPr>
-          <p:cNvPr id="113" name="Destaques 113"/>
+          <p:cNvPr id="112" name="Destaques 112"/>
           <p:cNvGrpSpPr/>
           <p:nvPr/>
         </p:nvGrpSpPr>
@@ -14493,7 +14003,7 @@
         </p:grpSpPr>
         <p:sp>
           <p:nvSpPr>
-            <p:cNvPr id="107" name="Cartão 107"/>
+            <p:cNvPr id="106" name="Cartão 106"/>
             <p:cNvSpPr/>
             <p:nvPr/>
           </p:nvSpPr>
@@ -14525,7 +14035,7 @@
         </p:sp>
         <p:sp>
           <p:nvSpPr>
-            <p:cNvPr id="108" name="Texto 108"/>
+            <p:cNvPr id="107" name="Texto 107"/>
             <p:cNvSpPr txBox="1"/>
             <p:nvPr/>
           </p:nvSpPr>
@@ -14571,7 +14081,7 @@
         </p:sp>
         <p:sp>
           <p:nvSpPr>
-            <p:cNvPr id="109" name="Cartão 109"/>
+            <p:cNvPr id="108" name="Cartão 108"/>
             <p:cNvSpPr/>
             <p:nvPr/>
           </p:nvSpPr>
@@ -14603,7 +14113,7 @@
         </p:sp>
         <p:sp>
           <p:nvSpPr>
-            <p:cNvPr id="110" name="Texto 110"/>
+            <p:cNvPr id="109" name="Texto 109"/>
             <p:cNvSpPr txBox="1"/>
             <p:nvPr/>
           </p:nvSpPr>
@@ -14649,7 +14159,7 @@
         </p:sp>
         <p:sp>
           <p:nvSpPr>
-            <p:cNvPr id="111" name="Cartão 111"/>
+            <p:cNvPr id="110" name="Cartão 110"/>
             <p:cNvSpPr/>
             <p:nvPr/>
           </p:nvSpPr>
@@ -14681,7 +14191,7 @@
         </p:sp>
         <p:sp>
           <p:nvSpPr>
-            <p:cNvPr id="112" name="Texto 112"/>
+            <p:cNvPr id="111" name="Texto 111"/>
             <p:cNvSpPr txBox="1"/>
             <p:nvPr/>
           </p:nvSpPr>
@@ -14771,7 +14281,7 @@
                                           </p:stCondLst>
                                         </p:cTn>
                                         <p:tgtEl>
-                                          <p:spTgt spid="105"/>
+                                          <p:spTgt spid="104"/>
                                         </p:tgtEl>
                                         <p:attrNameLst>
                                           <p:attrName>style.visibility</p:attrName>
@@ -14785,7 +14295,7 @@
                                       <p:cBhvr>
                                         <p:cTn id="7" dur="700"/>
                                         <p:tgtEl>
-                                          <p:spTgt spid="105"/>
+                                          <p:spTgt spid="104"/>
                                         </p:tgtEl>
                                       </p:cBhvr>
                                     </p:animEffect>
@@ -14806,7 +14316,7 @@
                                           </p:stCondLst>
                                         </p:cTn>
                                         <p:tgtEl>
-                                          <p:spTgt spid="106"/>
+                                          <p:spTgt spid="105"/>
                                         </p:tgtEl>
                                         <p:attrNameLst>
                                           <p:attrName>style.visibility</p:attrName>
@@ -14820,7 +14330,7 @@
                                       <p:cBhvr>
                                         <p:cTn id="10" dur="700"/>
                                         <p:tgtEl>
-                                          <p:spTgt spid="106"/>
+                                          <p:spTgt spid="105"/>
                                         </p:tgtEl>
                                       </p:cBhvr>
                                     </p:animEffect>
@@ -14841,7 +14351,7 @@
                                           </p:stCondLst>
                                         </p:cTn>
                                         <p:tgtEl>
-                                          <p:spTgt spid="113"/>
+                                          <p:spTgt spid="112"/>
                                         </p:tgtEl>
                                         <p:attrNameLst>
                                           <p:attrName>style.visibility</p:attrName>
@@ -14855,7 +14365,7 @@
                                       <p:cBhvr>
                                         <p:cTn id="13" dur="700"/>
                                         <p:tgtEl>
-                                          <p:spTgt spid="113"/>
+                                          <p:spTgt spid="112"/>
                                         </p:tgtEl>
                                       </p:cBhvr>
                                     </p:animEffect>
@@ -14890,8 +14400,8 @@
       </p:par>
     </p:tnLst>
     <p:bldLst>
+      <p:bldP spid="104" grpId="0"/>
       <p:bldP spid="105" grpId="0"/>
-      <p:bldP spid="106" grpId="0"/>
     </p:bldLst>
   </p:timing>
 </p:sld>
@@ -15561,65 +15071,7 @@
       </p:grpSp>
       <p:sp>
         <p:nvSpPr>
-          <p:cNvPr id="101" name="Cabeçalho 101"/>
-          <p:cNvSpPr txBox="1"/>
-          <p:nvPr/>
-        </p:nvSpPr>
-        <p:spPr>
-          <a:xfrm>
-            <a:off x="1024128" y="932688"/>
-            <a:ext cx="13533120" cy="411480"/>
-          </a:xfrm>
-          <a:prstGeom prst="rect">
-            <a:avLst/>
-          </a:prstGeom>
-          <a:noFill/>
-        </p:spPr>
-        <p:txBody>
-          <a:bodyPr wrap="square" lIns="0" tIns="0" rIns="0" bIns="0" anchor="t" rtlCol="0">
-            <a:noAutofit/>
-          </a:bodyPr>
-          <a:lstStyle/>
-          <a:p>
-            <a:pPr algn="l">
-              <a:spcBef>
-                <a:spcPts val="0"/>
-              </a:spcBef>
-              <a:spcAft>
-                <a:spcPts val="0"/>
-              </a:spcAft>
-              <a:buNone/>
-            </a:pPr>
-            <a:r>
-              <a:rPr lang="pt-BR" sz="1900">
-                <a:solidFill>
-                  <a:srgbClr val="3E721D"/>
-                </a:solidFill>
-                <a:latin typeface="Garet"/>
-                <a:ea typeface="Garet"/>
-                <a:cs typeface="Garet"/>
-                <a:sym typeface="Garet"/>
-              </a:rPr>
-              <a:t xml:space="preserve">Apresentado por  </a:t>
-            </a:r>
-            <a:r>
-              <a:rPr lang="pt-BR" sz="1900" b="1">
-                <a:solidFill>
-                  <a:srgbClr val="3E721D"/>
-                </a:solidFill>
-                <a:latin typeface="Garet Bold"/>
-                <a:ea typeface="Garet Bold"/>
-                <a:cs typeface="Garet Bold"/>
-                <a:sym typeface="Garet Bold"/>
-              </a:rPr>
-              <a:t>Matheus Rosa, Gabriely Paixão, Yvana Lopes, Milena Vitória e Myriam Caires</a:t>
-            </a:r>
-          </a:p>
-        </p:txBody>
-      </p:sp>
-      <p:sp>
-        <p:nvSpPr>
-          <p:cNvPr id="102" name="Ano 102"/>
+          <p:cNvPr id="101" name="Ano 101"/>
           <p:cNvSpPr txBox="1"/>
           <p:nvPr/>
         </p:nvSpPr>
@@ -15665,7 +15117,7 @@
       </p:sp>
       <p:sp>
         <p:nvSpPr>
-          <p:cNvPr id="103" name="Rodapé 103"/>
+          <p:cNvPr id="102" name="Rodapé 102"/>
           <p:cNvSpPr txBox="1"/>
           <p:nvPr/>
         </p:nvSpPr>
@@ -15711,7 +15163,7 @@
       </p:sp>
       <p:sp>
         <p:nvSpPr>
-          <p:cNvPr id="104" name="Página 104"/>
+          <p:cNvPr id="103" name="Página 103"/>
           <p:cNvSpPr txBox="1"/>
           <p:nvPr/>
         </p:nvSpPr>
@@ -15757,7 +15209,7 @@
       </p:sp>
       <p:sp>
         <p:nvSpPr>
-          <p:cNvPr id="105" name="Título 105"/>
+          <p:cNvPr id="104" name="Título 104"/>
           <p:cNvSpPr txBox="1"/>
           <p:nvPr/>
         </p:nvSpPr>
@@ -15806,7 +15258,7 @@
       </p:sp>
       <p:grpSp>
         <p:nvGrpSpPr>
-          <p:cNvPr id="109" name="Coluna 109"/>
+          <p:cNvPr id="108" name="Coluna 108"/>
           <p:cNvGrpSpPr/>
           <p:nvPr/>
         </p:nvGrpSpPr>
@@ -15820,7 +15272,7 @@
         </p:grpSpPr>
         <p:sp>
           <p:nvSpPr>
-            <p:cNvPr id="106" name="Cartão 106"/>
+            <p:cNvPr id="105" name="Cartão 105"/>
             <p:cNvSpPr/>
             <p:nvPr/>
           </p:nvSpPr>
@@ -15852,7 +15304,7 @@
         </p:sp>
         <p:sp>
           <p:nvSpPr>
-            <p:cNvPr id="107" name="Texto 107"/>
+            <p:cNvPr id="106" name="Texto 106"/>
             <p:cNvSpPr txBox="1"/>
             <p:nvPr/>
           </p:nvSpPr>
@@ -15898,7 +15350,7 @@
         </p:sp>
         <p:sp>
           <p:nvSpPr>
-            <p:cNvPr id="108" name="Texto 108"/>
+            <p:cNvPr id="107" name="Texto 107"/>
             <p:cNvSpPr txBox="1"/>
             <p:nvPr/>
           </p:nvSpPr>
@@ -15974,7 +15426,7 @@
       </p:grpSp>
       <p:grpSp>
         <p:nvGrpSpPr>
-          <p:cNvPr id="113" name="Coluna 113"/>
+          <p:cNvPr id="112" name="Coluna 112"/>
           <p:cNvGrpSpPr/>
           <p:nvPr/>
         </p:nvGrpSpPr>
@@ -15988,7 +15440,7 @@
         </p:grpSpPr>
         <p:sp>
           <p:nvSpPr>
-            <p:cNvPr id="110" name="Cartão 110"/>
+            <p:cNvPr id="109" name="Cartão 109"/>
             <p:cNvSpPr/>
             <p:nvPr/>
           </p:nvSpPr>
@@ -16020,7 +15472,7 @@
         </p:sp>
         <p:sp>
           <p:nvSpPr>
-            <p:cNvPr id="111" name="Texto 111"/>
+            <p:cNvPr id="110" name="Texto 110"/>
             <p:cNvSpPr txBox="1"/>
             <p:nvPr/>
           </p:nvSpPr>
@@ -16066,7 +15518,7 @@
         </p:sp>
         <p:sp>
           <p:nvSpPr>
-            <p:cNvPr id="112" name="Texto 112"/>
+            <p:cNvPr id="111" name="Texto 111"/>
             <p:cNvSpPr txBox="1"/>
             <p:nvPr/>
           </p:nvSpPr>
@@ -16166,7 +15618,7 @@
       </p:grpSp>
       <p:grpSp>
         <p:nvGrpSpPr>
-          <p:cNvPr id="117" name="Coluna 117"/>
+          <p:cNvPr id="116" name="Coluna 116"/>
           <p:cNvGrpSpPr/>
           <p:nvPr/>
         </p:nvGrpSpPr>
@@ -16180,7 +15632,7 @@
         </p:grpSpPr>
         <p:sp>
           <p:nvSpPr>
-            <p:cNvPr id="114" name="Cartão 114"/>
+            <p:cNvPr id="113" name="Cartão 113"/>
             <p:cNvSpPr/>
             <p:nvPr/>
           </p:nvSpPr>
@@ -16212,7 +15664,7 @@
         </p:sp>
         <p:sp>
           <p:nvSpPr>
-            <p:cNvPr id="115" name="Texto 115"/>
+            <p:cNvPr id="114" name="Texto 114"/>
             <p:cNvSpPr txBox="1"/>
             <p:nvPr/>
           </p:nvSpPr>
@@ -16258,7 +15710,7 @@
         </p:sp>
         <p:sp>
           <p:nvSpPr>
-            <p:cNvPr id="116" name="Texto 116"/>
+            <p:cNvPr id="115" name="Texto 115"/>
             <p:cNvSpPr txBox="1"/>
             <p:nvPr/>
           </p:nvSpPr>
@@ -16401,7 +15853,7 @@
                                           </p:stCondLst>
                                         </p:cTn>
                                         <p:tgtEl>
-                                          <p:spTgt spid="105"/>
+                                          <p:spTgt spid="104"/>
                                         </p:tgtEl>
                                         <p:attrNameLst>
                                           <p:attrName>style.visibility</p:attrName>
@@ -16415,7 +15867,7 @@
                                       <p:cBhvr>
                                         <p:cTn id="7" dur="700"/>
                                         <p:tgtEl>
-                                          <p:spTgt spid="105"/>
+                                          <p:spTgt spid="104"/>
                                         </p:tgtEl>
                                       </p:cBhvr>
                                     </p:animEffect>
@@ -16436,7 +15888,7 @@
                                           </p:stCondLst>
                                         </p:cTn>
                                         <p:tgtEl>
-                                          <p:spTgt spid="109"/>
+                                          <p:spTgt spid="108"/>
                                         </p:tgtEl>
                                         <p:attrNameLst>
                                           <p:attrName>style.visibility</p:attrName>
@@ -16450,7 +15902,7 @@
                                       <p:cBhvr>
                                         <p:cTn id="10" dur="700"/>
                                         <p:tgtEl>
-                                          <p:spTgt spid="109"/>
+                                          <p:spTgt spid="108"/>
                                         </p:tgtEl>
                                       </p:cBhvr>
                                     </p:animEffect>
@@ -16471,7 +15923,7 @@
                                           </p:stCondLst>
                                         </p:cTn>
                                         <p:tgtEl>
-                                          <p:spTgt spid="113"/>
+                                          <p:spTgt spid="112"/>
                                         </p:tgtEl>
                                         <p:attrNameLst>
                                           <p:attrName>style.visibility</p:attrName>
@@ -16485,7 +15937,7 @@
                                       <p:cBhvr>
                                         <p:cTn id="13" dur="700"/>
                                         <p:tgtEl>
-                                          <p:spTgt spid="113"/>
+                                          <p:spTgt spid="112"/>
                                         </p:tgtEl>
                                       </p:cBhvr>
                                     </p:animEffect>
@@ -16506,7 +15958,7 @@
                                           </p:stCondLst>
                                         </p:cTn>
                                         <p:tgtEl>
-                                          <p:spTgt spid="117"/>
+                                          <p:spTgt spid="116"/>
                                         </p:tgtEl>
                                         <p:attrNameLst>
                                           <p:attrName>style.visibility</p:attrName>
@@ -16520,7 +15972,7 @@
                                       <p:cBhvr>
                                         <p:cTn id="16" dur="700"/>
                                         <p:tgtEl>
-                                          <p:spTgt spid="117"/>
+                                          <p:spTgt spid="116"/>
                                         </p:tgtEl>
                                       </p:cBhvr>
                                     </p:animEffect>
@@ -16555,7 +16007,7 @@
       </p:par>
     </p:tnLst>
     <p:bldLst>
-      <p:bldP spid="105" grpId="0"/>
+      <p:bldP spid="104" grpId="0"/>
     </p:bldLst>
   </p:timing>
 </p:sld>
@@ -17225,65 +16677,7 @@
       </p:grpSp>
       <p:sp>
         <p:nvSpPr>
-          <p:cNvPr id="101" name="Cabeçalho 101"/>
-          <p:cNvSpPr txBox="1"/>
-          <p:nvPr/>
-        </p:nvSpPr>
-        <p:spPr>
-          <a:xfrm>
-            <a:off x="1024128" y="932688"/>
-            <a:ext cx="13533120" cy="411480"/>
-          </a:xfrm>
-          <a:prstGeom prst="rect">
-            <a:avLst/>
-          </a:prstGeom>
-          <a:noFill/>
-        </p:spPr>
-        <p:txBody>
-          <a:bodyPr wrap="square" lIns="0" tIns="0" rIns="0" bIns="0" anchor="t" rtlCol="0">
-            <a:noAutofit/>
-          </a:bodyPr>
-          <a:lstStyle/>
-          <a:p>
-            <a:pPr algn="l">
-              <a:spcBef>
-                <a:spcPts val="0"/>
-              </a:spcBef>
-              <a:spcAft>
-                <a:spcPts val="0"/>
-              </a:spcAft>
-              <a:buNone/>
-            </a:pPr>
-            <a:r>
-              <a:rPr lang="pt-BR" sz="1900">
-                <a:solidFill>
-                  <a:srgbClr val="3E721D"/>
-                </a:solidFill>
-                <a:latin typeface="Garet"/>
-                <a:ea typeface="Garet"/>
-                <a:cs typeface="Garet"/>
-                <a:sym typeface="Garet"/>
-              </a:rPr>
-              <a:t xml:space="preserve">Apresentado por  </a:t>
-            </a:r>
-            <a:r>
-              <a:rPr lang="pt-BR" sz="1900" b="1">
-                <a:solidFill>
-                  <a:srgbClr val="3E721D"/>
-                </a:solidFill>
-                <a:latin typeface="Garet Bold"/>
-                <a:ea typeface="Garet Bold"/>
-                <a:cs typeface="Garet Bold"/>
-                <a:sym typeface="Garet Bold"/>
-              </a:rPr>
-              <a:t>Matheus Rosa, Gabriely Paixão, Yvana Lopes, Milena Vitória e Myriam Caires</a:t>
-            </a:r>
-          </a:p>
-        </p:txBody>
-      </p:sp>
-      <p:sp>
-        <p:nvSpPr>
-          <p:cNvPr id="102" name="Ano 102"/>
+          <p:cNvPr id="101" name="Ano 101"/>
           <p:cNvSpPr txBox="1"/>
           <p:nvPr/>
         </p:nvSpPr>
@@ -17329,7 +16723,7 @@
       </p:sp>
       <p:sp>
         <p:nvSpPr>
-          <p:cNvPr id="103" name="Rodapé 103"/>
+          <p:cNvPr id="102" name="Rodapé 102"/>
           <p:cNvSpPr txBox="1"/>
           <p:nvPr/>
         </p:nvSpPr>
@@ -17375,7 +16769,7 @@
       </p:sp>
       <p:sp>
         <p:nvSpPr>
-          <p:cNvPr id="104" name="Página 104"/>
+          <p:cNvPr id="103" name="Página 103"/>
           <p:cNvSpPr txBox="1"/>
           <p:nvPr/>
         </p:nvSpPr>
@@ -17421,7 +16815,7 @@
       </p:sp>
       <p:sp>
         <p:nvSpPr>
-          <p:cNvPr id="105" name="Título 105"/>
+          <p:cNvPr id="104" name="Título 104"/>
           <p:cNvSpPr txBox="1"/>
           <p:nvPr/>
         </p:nvSpPr>
@@ -17470,7 +16864,7 @@
       </p:sp>
       <p:grpSp>
         <p:nvGrpSpPr>
-          <p:cNvPr id="109" name="Nível 109"/>
+          <p:cNvPr id="108" name="Nível 108"/>
           <p:cNvGrpSpPr/>
           <p:nvPr/>
         </p:nvGrpSpPr>
@@ -17484,7 +16878,7 @@
         </p:grpSpPr>
         <p:sp>
           <p:nvSpPr>
-            <p:cNvPr id="106" name="Cartão 106"/>
+            <p:cNvPr id="105" name="Cartão 105"/>
             <p:cNvSpPr/>
             <p:nvPr/>
           </p:nvSpPr>
@@ -17516,7 +16910,7 @@
         </p:sp>
         <p:sp>
           <p:nvSpPr>
-            <p:cNvPr id="107" name="Texto 107"/>
+            <p:cNvPr id="106" name="Texto 106"/>
             <p:cNvSpPr txBox="1"/>
             <p:nvPr/>
           </p:nvSpPr>
@@ -17562,7 +16956,7 @@
         </p:sp>
         <p:sp>
           <p:nvSpPr>
-            <p:cNvPr id="108" name="Texto 108"/>
+            <p:cNvPr id="107" name="Texto 107"/>
             <p:cNvSpPr txBox="1"/>
             <p:nvPr/>
           </p:nvSpPr>
@@ -17609,7 +17003,7 @@
       </p:grpSp>
       <p:grpSp>
         <p:nvGrpSpPr>
-          <p:cNvPr id="113" name="Nível 113"/>
+          <p:cNvPr id="112" name="Nível 112"/>
           <p:cNvGrpSpPr/>
           <p:nvPr/>
         </p:nvGrpSpPr>
@@ -17623,7 +17017,7 @@
         </p:grpSpPr>
         <p:sp>
           <p:nvSpPr>
-            <p:cNvPr id="110" name="Cartão 110"/>
+            <p:cNvPr id="109" name="Cartão 109"/>
             <p:cNvSpPr/>
             <p:nvPr/>
           </p:nvSpPr>
@@ -17655,7 +17049,7 @@
         </p:sp>
         <p:sp>
           <p:nvSpPr>
-            <p:cNvPr id="111" name="Texto 111"/>
+            <p:cNvPr id="110" name="Texto 110"/>
             <p:cNvSpPr txBox="1"/>
             <p:nvPr/>
           </p:nvSpPr>
@@ -17701,7 +17095,7 @@
         </p:sp>
         <p:sp>
           <p:nvSpPr>
-            <p:cNvPr id="112" name="Texto 112"/>
+            <p:cNvPr id="111" name="Texto 111"/>
             <p:cNvSpPr txBox="1"/>
             <p:nvPr/>
           </p:nvSpPr>
@@ -17760,7 +17154,7 @@
       </p:grpSp>
       <p:grpSp>
         <p:nvGrpSpPr>
-          <p:cNvPr id="117" name="Nível 117"/>
+          <p:cNvPr id="116" name="Nível 116"/>
           <p:cNvGrpSpPr/>
           <p:nvPr/>
         </p:nvGrpSpPr>
@@ -17774,7 +17168,7 @@
         </p:grpSpPr>
         <p:sp>
           <p:nvSpPr>
-            <p:cNvPr id="114" name="Cartão 114"/>
+            <p:cNvPr id="113" name="Cartão 113"/>
             <p:cNvSpPr/>
             <p:nvPr/>
           </p:nvSpPr>
@@ -17806,7 +17200,7 @@
         </p:sp>
         <p:sp>
           <p:nvSpPr>
-            <p:cNvPr id="115" name="Texto 115"/>
+            <p:cNvPr id="114" name="Texto 114"/>
             <p:cNvSpPr txBox="1"/>
             <p:nvPr/>
           </p:nvSpPr>
@@ -17852,7 +17246,7 @@
         </p:sp>
         <p:sp>
           <p:nvSpPr>
-            <p:cNvPr id="116" name="Texto 116"/>
+            <p:cNvPr id="115" name="Texto 115"/>
             <p:cNvSpPr txBox="1"/>
             <p:nvPr/>
           </p:nvSpPr>
@@ -17899,7 +17293,7 @@
       </p:grpSp>
       <p:grpSp>
         <p:nvGrpSpPr>
-          <p:cNvPr id="121" name="Nível 121"/>
+          <p:cNvPr id="120" name="Nível 120"/>
           <p:cNvGrpSpPr/>
           <p:nvPr/>
         </p:nvGrpSpPr>
@@ -17913,7 +17307,7 @@
         </p:grpSpPr>
         <p:sp>
           <p:nvSpPr>
-            <p:cNvPr id="118" name="Cartão 118"/>
+            <p:cNvPr id="117" name="Cartão 117"/>
             <p:cNvSpPr/>
             <p:nvPr/>
           </p:nvSpPr>
@@ -17945,7 +17339,7 @@
         </p:sp>
         <p:sp>
           <p:nvSpPr>
-            <p:cNvPr id="119" name="Texto 119"/>
+            <p:cNvPr id="118" name="Texto 118"/>
             <p:cNvSpPr txBox="1"/>
             <p:nvPr/>
           </p:nvSpPr>
@@ -17991,7 +17385,7 @@
         </p:sp>
         <p:sp>
           <p:nvSpPr>
-            <p:cNvPr id="120" name="Texto 120"/>
+            <p:cNvPr id="119" name="Texto 119"/>
             <p:cNvSpPr txBox="1"/>
             <p:nvPr/>
           </p:nvSpPr>
@@ -18038,7 +17432,7 @@
       </p:grpSp>
       <p:grpSp>
         <p:nvGrpSpPr>
-          <p:cNvPr id="125" name="Nível 125"/>
+          <p:cNvPr id="124" name="Nível 124"/>
           <p:cNvGrpSpPr/>
           <p:nvPr/>
         </p:nvGrpSpPr>
@@ -18052,7 +17446,7 @@
         </p:grpSpPr>
         <p:sp>
           <p:nvSpPr>
-            <p:cNvPr id="122" name="Cartão 122"/>
+            <p:cNvPr id="121" name="Cartão 121"/>
             <p:cNvSpPr/>
             <p:nvPr/>
           </p:nvSpPr>
@@ -18084,7 +17478,7 @@
         </p:sp>
         <p:sp>
           <p:nvSpPr>
-            <p:cNvPr id="123" name="Texto 123"/>
+            <p:cNvPr id="122" name="Texto 122"/>
             <p:cNvSpPr txBox="1"/>
             <p:nvPr/>
           </p:nvSpPr>
@@ -18130,7 +17524,7 @@
         </p:sp>
         <p:sp>
           <p:nvSpPr>
-            <p:cNvPr id="124" name="Texto 124"/>
+            <p:cNvPr id="123" name="Texto 123"/>
             <p:cNvSpPr txBox="1"/>
             <p:nvPr/>
           </p:nvSpPr>
@@ -18177,7 +17571,7 @@
       </p:grpSp>
       <p:grpSp>
         <p:nvGrpSpPr>
-          <p:cNvPr id="129" name="Nível 129"/>
+          <p:cNvPr id="128" name="Nível 128"/>
           <p:cNvGrpSpPr/>
           <p:nvPr/>
         </p:nvGrpSpPr>
@@ -18191,7 +17585,7 @@
         </p:grpSpPr>
         <p:sp>
           <p:nvSpPr>
-            <p:cNvPr id="126" name="Cartão 126"/>
+            <p:cNvPr id="125" name="Cartão 125"/>
             <p:cNvSpPr/>
             <p:nvPr/>
           </p:nvSpPr>
@@ -18223,7 +17617,7 @@
         </p:sp>
         <p:sp>
           <p:nvSpPr>
-            <p:cNvPr id="127" name="Texto 127"/>
+            <p:cNvPr id="126" name="Texto 126"/>
             <p:cNvSpPr txBox="1"/>
             <p:nvPr/>
           </p:nvSpPr>
@@ -18269,7 +17663,7 @@
         </p:sp>
         <p:sp>
           <p:nvSpPr>
-            <p:cNvPr id="128" name="Texto 128"/>
+            <p:cNvPr id="127" name="Texto 127"/>
             <p:cNvSpPr txBox="1"/>
             <p:nvPr/>
           </p:nvSpPr>
@@ -18316,7 +17710,7 @@
       </p:grpSp>
       <p:grpSp>
         <p:nvGrpSpPr>
-          <p:cNvPr id="133" name="Nível 133"/>
+          <p:cNvPr id="132" name="Nível 132"/>
           <p:cNvGrpSpPr/>
           <p:nvPr/>
         </p:nvGrpSpPr>
@@ -18330,7 +17724,7 @@
         </p:grpSpPr>
         <p:sp>
           <p:nvSpPr>
-            <p:cNvPr id="130" name="Cartão 130"/>
+            <p:cNvPr id="129" name="Cartão 129"/>
             <p:cNvSpPr/>
             <p:nvPr/>
           </p:nvSpPr>
@@ -18362,7 +17756,7 @@
         </p:sp>
         <p:sp>
           <p:nvSpPr>
-            <p:cNvPr id="131" name="Texto 131"/>
+            <p:cNvPr id="130" name="Texto 130"/>
             <p:cNvSpPr txBox="1"/>
             <p:nvPr/>
           </p:nvSpPr>
@@ -18408,7 +17802,7 @@
         </p:sp>
         <p:sp>
           <p:nvSpPr>
-            <p:cNvPr id="132" name="Texto 132"/>
+            <p:cNvPr id="131" name="Texto 131"/>
             <p:cNvSpPr txBox="1"/>
             <p:nvPr/>
           </p:nvSpPr>
@@ -18479,7 +17873,7 @@
       </p:grpSp>
       <p:grpSp>
         <p:nvGrpSpPr>
-          <p:cNvPr id="136" name="Nota 136"/>
+          <p:cNvPr id="135" name="Nota 135"/>
           <p:cNvGrpSpPr/>
           <p:nvPr/>
         </p:nvGrpSpPr>
@@ -18493,7 +17887,7 @@
         </p:grpSpPr>
         <p:sp>
           <p:nvSpPr>
-            <p:cNvPr id="134" name="Cartão 134"/>
+            <p:cNvPr id="133" name="Cartão 133"/>
             <p:cNvSpPr/>
             <p:nvPr/>
           </p:nvSpPr>
@@ -18525,7 +17919,7 @@
         </p:sp>
         <p:sp>
           <p:nvSpPr>
-            <p:cNvPr id="135" name="Texto 135"/>
+            <p:cNvPr id="134" name="Texto 134"/>
             <p:cNvSpPr txBox="1"/>
             <p:nvPr/>
           </p:nvSpPr>
@@ -18716,7 +18110,7 @@
                                           </p:stCondLst>
                                         </p:cTn>
                                         <p:tgtEl>
-                                          <p:spTgt spid="105"/>
+                                          <p:spTgt spid="104"/>
                                         </p:tgtEl>
                                         <p:attrNameLst>
                                           <p:attrName>style.visibility</p:attrName>
@@ -18730,7 +18124,7 @@
                                       <p:cBhvr>
                                         <p:cTn id="7" dur="700"/>
                                         <p:tgtEl>
-                                          <p:spTgt spid="105"/>
+                                          <p:spTgt spid="104"/>
                                         </p:tgtEl>
                                       </p:cBhvr>
                                     </p:animEffect>
@@ -18751,7 +18145,7 @@
                                           </p:stCondLst>
                                         </p:cTn>
                                         <p:tgtEl>
-                                          <p:spTgt spid="109"/>
+                                          <p:spTgt spid="108"/>
                                         </p:tgtEl>
                                         <p:attrNameLst>
                                           <p:attrName>style.visibility</p:attrName>
@@ -18765,7 +18159,7 @@
                                       <p:cBhvr>
                                         <p:cTn id="10" dur="700"/>
                                         <p:tgtEl>
-                                          <p:spTgt spid="109"/>
+                                          <p:spTgt spid="108"/>
                                         </p:tgtEl>
                                       </p:cBhvr>
                                     </p:animEffect>
@@ -18786,7 +18180,7 @@
                                           </p:stCondLst>
                                         </p:cTn>
                                         <p:tgtEl>
-                                          <p:spTgt spid="113"/>
+                                          <p:spTgt spid="112"/>
                                         </p:tgtEl>
                                         <p:attrNameLst>
                                           <p:attrName>style.visibility</p:attrName>
@@ -18800,7 +18194,7 @@
                                       <p:cBhvr>
                                         <p:cTn id="13" dur="700"/>
                                         <p:tgtEl>
-                                          <p:spTgt spid="113"/>
+                                          <p:spTgt spid="112"/>
                                         </p:tgtEl>
                                       </p:cBhvr>
                                     </p:animEffect>
@@ -18821,7 +18215,7 @@
                                           </p:stCondLst>
                                         </p:cTn>
                                         <p:tgtEl>
-                                          <p:spTgt spid="117"/>
+                                          <p:spTgt spid="116"/>
                                         </p:tgtEl>
                                         <p:attrNameLst>
                                           <p:attrName>style.visibility</p:attrName>
@@ -18835,7 +18229,7 @@
                                       <p:cBhvr>
                                         <p:cTn id="16" dur="700"/>
                                         <p:tgtEl>
-                                          <p:spTgt spid="117"/>
+                                          <p:spTgt spid="116"/>
                                         </p:tgtEl>
                                       </p:cBhvr>
                                     </p:animEffect>
@@ -18856,7 +18250,7 @@
                                           </p:stCondLst>
                                         </p:cTn>
                                         <p:tgtEl>
-                                          <p:spTgt spid="121"/>
+                                          <p:spTgt spid="120"/>
                                         </p:tgtEl>
                                         <p:attrNameLst>
                                           <p:attrName>style.visibility</p:attrName>
@@ -18870,7 +18264,7 @@
                                       <p:cBhvr>
                                         <p:cTn id="19" dur="700"/>
                                         <p:tgtEl>
-                                          <p:spTgt spid="121"/>
+                                          <p:spTgt spid="120"/>
                                         </p:tgtEl>
                                       </p:cBhvr>
                                     </p:animEffect>
@@ -18891,7 +18285,7 @@
                                           </p:stCondLst>
                                         </p:cTn>
                                         <p:tgtEl>
-                                          <p:spTgt spid="125"/>
+                                          <p:spTgt spid="124"/>
                                         </p:tgtEl>
                                         <p:attrNameLst>
                                           <p:attrName>style.visibility</p:attrName>
@@ -18905,7 +18299,7 @@
                                       <p:cBhvr>
                                         <p:cTn id="22" dur="700"/>
                                         <p:tgtEl>
-                                          <p:spTgt spid="125"/>
+                                          <p:spTgt spid="124"/>
                                         </p:tgtEl>
                                       </p:cBhvr>
                                     </p:animEffect>
@@ -18926,7 +18320,7 @@
                                           </p:stCondLst>
                                         </p:cTn>
                                         <p:tgtEl>
-                                          <p:spTgt spid="129"/>
+                                          <p:spTgt spid="128"/>
                                         </p:tgtEl>
                                         <p:attrNameLst>
                                           <p:attrName>style.visibility</p:attrName>
@@ -18940,7 +18334,7 @@
                                       <p:cBhvr>
                                         <p:cTn id="25" dur="700"/>
                                         <p:tgtEl>
-                                          <p:spTgt spid="129"/>
+                                          <p:spTgt spid="128"/>
                                         </p:tgtEl>
                                       </p:cBhvr>
                                     </p:animEffect>
@@ -18961,7 +18355,7 @@
                                           </p:stCondLst>
                                         </p:cTn>
                                         <p:tgtEl>
-                                          <p:spTgt spid="133"/>
+                                          <p:spTgt spid="132"/>
                                         </p:tgtEl>
                                         <p:attrNameLst>
                                           <p:attrName>style.visibility</p:attrName>
@@ -18975,7 +18369,7 @@
                                       <p:cBhvr>
                                         <p:cTn id="28" dur="700"/>
                                         <p:tgtEl>
-                                          <p:spTgt spid="133"/>
+                                          <p:spTgt spid="132"/>
                                         </p:tgtEl>
                                       </p:cBhvr>
                                     </p:animEffect>
@@ -18996,7 +18390,7 @@
                                           </p:stCondLst>
                                         </p:cTn>
                                         <p:tgtEl>
-                                          <p:spTgt spid="136"/>
+                                          <p:spTgt spid="135"/>
                                         </p:tgtEl>
                                         <p:attrNameLst>
                                           <p:attrName>style.visibility</p:attrName>
@@ -19010,7 +18404,7 @@
                                       <p:cBhvr>
                                         <p:cTn id="31" dur="700"/>
                                         <p:tgtEl>
-                                          <p:spTgt spid="136"/>
+                                          <p:spTgt spid="135"/>
                                         </p:tgtEl>
                                       </p:cBhvr>
                                     </p:animEffect>
@@ -19045,7 +18439,7 @@
       </p:par>
     </p:tnLst>
     <p:bldLst>
-      <p:bldP spid="105" grpId="0"/>
+      <p:bldP spid="104" grpId="0"/>
     </p:bldLst>
   </p:timing>
 </p:sld>
@@ -19715,65 +19109,7 @@
       </p:grpSp>
       <p:sp>
         <p:nvSpPr>
-          <p:cNvPr id="101" name="Cabeçalho 101"/>
-          <p:cNvSpPr txBox="1"/>
-          <p:nvPr/>
-        </p:nvSpPr>
-        <p:spPr>
-          <a:xfrm>
-            <a:off x="1024128" y="932688"/>
-            <a:ext cx="13533120" cy="411480"/>
-          </a:xfrm>
-          <a:prstGeom prst="rect">
-            <a:avLst/>
-          </a:prstGeom>
-          <a:noFill/>
-        </p:spPr>
-        <p:txBody>
-          <a:bodyPr wrap="square" lIns="0" tIns="0" rIns="0" bIns="0" anchor="t" rtlCol="0">
-            <a:noAutofit/>
-          </a:bodyPr>
-          <a:lstStyle/>
-          <a:p>
-            <a:pPr algn="l">
-              <a:spcBef>
-                <a:spcPts val="0"/>
-              </a:spcBef>
-              <a:spcAft>
-                <a:spcPts val="0"/>
-              </a:spcAft>
-              <a:buNone/>
-            </a:pPr>
-            <a:r>
-              <a:rPr lang="pt-BR" sz="1900">
-                <a:solidFill>
-                  <a:srgbClr val="3E721D"/>
-                </a:solidFill>
-                <a:latin typeface="Garet"/>
-                <a:ea typeface="Garet"/>
-                <a:cs typeface="Garet"/>
-                <a:sym typeface="Garet"/>
-              </a:rPr>
-              <a:t xml:space="preserve">Apresentado por  </a:t>
-            </a:r>
-            <a:r>
-              <a:rPr lang="pt-BR" sz="1900" b="1">
-                <a:solidFill>
-                  <a:srgbClr val="3E721D"/>
-                </a:solidFill>
-                <a:latin typeface="Garet Bold"/>
-                <a:ea typeface="Garet Bold"/>
-                <a:cs typeface="Garet Bold"/>
-                <a:sym typeface="Garet Bold"/>
-              </a:rPr>
-              <a:t>Matheus Rosa, Gabriely Paixão, Yvana Lopes, Milena Vitória e Myriam Caires</a:t>
-            </a:r>
-          </a:p>
-        </p:txBody>
-      </p:sp>
-      <p:sp>
-        <p:nvSpPr>
-          <p:cNvPr id="102" name="Ano 102"/>
+          <p:cNvPr id="101" name="Ano 101"/>
           <p:cNvSpPr txBox="1"/>
           <p:nvPr/>
         </p:nvSpPr>
@@ -19819,7 +19155,7 @@
       </p:sp>
       <p:sp>
         <p:nvSpPr>
-          <p:cNvPr id="103" name="Rodapé 103"/>
+          <p:cNvPr id="102" name="Rodapé 102"/>
           <p:cNvSpPr txBox="1"/>
           <p:nvPr/>
         </p:nvSpPr>
@@ -19865,7 +19201,7 @@
       </p:sp>
       <p:sp>
         <p:nvSpPr>
-          <p:cNvPr id="104" name="Página 104"/>
+          <p:cNvPr id="103" name="Página 103"/>
           <p:cNvSpPr txBox="1"/>
           <p:nvPr/>
         </p:nvSpPr>
@@ -19911,7 +19247,7 @@
       </p:sp>
       <p:sp>
         <p:nvSpPr>
-          <p:cNvPr id="105" name="Título 105"/>
+          <p:cNvPr id="104" name="Título 104"/>
           <p:cNvSpPr txBox="1"/>
           <p:nvPr/>
         </p:nvSpPr>
@@ -19986,7 +19322,7 @@
       </p:sp>
       <p:grpSp>
         <p:nvGrpSpPr>
-          <p:cNvPr id="108" name="Cartão 108"/>
+          <p:cNvPr id="107" name="Cartão 107"/>
           <p:cNvGrpSpPr/>
           <p:nvPr/>
         </p:nvGrpSpPr>
@@ -20000,7 +19336,7 @@
         </p:grpSpPr>
         <p:sp>
           <p:nvSpPr>
-            <p:cNvPr id="106" name="Cartão 106"/>
+            <p:cNvPr id="105" name="Cartão 105"/>
             <p:cNvSpPr/>
             <p:nvPr/>
           </p:nvSpPr>
@@ -20032,7 +19368,7 @@
         </p:sp>
         <p:sp>
           <p:nvSpPr>
-            <p:cNvPr id="107" name="Texto 107"/>
+            <p:cNvPr id="106" name="Texto 106"/>
             <p:cNvSpPr txBox="1"/>
             <p:nvPr/>
           </p:nvSpPr>
@@ -20132,7 +19468,7 @@
       </p:grpSp>
       <p:grpSp>
         <p:nvGrpSpPr>
-          <p:cNvPr id="111" name="Cartão 111"/>
+          <p:cNvPr id="110" name="Cartão 110"/>
           <p:cNvGrpSpPr/>
           <p:nvPr/>
         </p:nvGrpSpPr>
@@ -20146,7 +19482,7 @@
         </p:grpSpPr>
         <p:sp>
           <p:nvSpPr>
-            <p:cNvPr id="109" name="Cartão 109"/>
+            <p:cNvPr id="108" name="Cartão 108"/>
             <p:cNvSpPr/>
             <p:nvPr/>
           </p:nvSpPr>
@@ -20178,7 +19514,7 @@
         </p:sp>
         <p:sp>
           <p:nvSpPr>
-            <p:cNvPr id="110" name="Texto 110"/>
+            <p:cNvPr id="109" name="Texto 109"/>
             <p:cNvSpPr txBox="1"/>
             <p:nvPr/>
           </p:nvSpPr>
@@ -20254,7 +19590,7 @@
       </p:grpSp>
       <p:grpSp>
         <p:nvGrpSpPr>
-          <p:cNvPr id="114" name="Cartão 114"/>
+          <p:cNvPr id="113" name="Cartão 113"/>
           <p:cNvGrpSpPr/>
           <p:nvPr/>
         </p:nvGrpSpPr>
@@ -20268,7 +19604,7 @@
         </p:grpSpPr>
         <p:sp>
           <p:nvSpPr>
-            <p:cNvPr id="112" name="Cartão 112"/>
+            <p:cNvPr id="111" name="Cartão 111"/>
             <p:cNvSpPr/>
             <p:nvPr/>
           </p:nvSpPr>
@@ -20300,7 +19636,7 @@
         </p:sp>
         <p:sp>
           <p:nvSpPr>
-            <p:cNvPr id="113" name="Texto 113"/>
+            <p:cNvPr id="112" name="Texto 112"/>
             <p:cNvSpPr txBox="1"/>
             <p:nvPr/>
           </p:nvSpPr>
@@ -20376,7 +19712,7 @@
       </p:grpSp>
       <p:grpSp>
         <p:nvGrpSpPr>
-          <p:cNvPr id="117" name="Cartão 117"/>
+          <p:cNvPr id="116" name="Cartão 116"/>
           <p:cNvGrpSpPr/>
           <p:nvPr/>
         </p:nvGrpSpPr>
@@ -20390,7 +19726,7 @@
         </p:grpSpPr>
         <p:sp>
           <p:nvSpPr>
-            <p:cNvPr id="115" name="Cartão 115"/>
+            <p:cNvPr id="114" name="Cartão 114"/>
             <p:cNvSpPr/>
             <p:nvPr/>
           </p:nvSpPr>
@@ -20422,7 +19758,7 @@
         </p:sp>
         <p:sp>
           <p:nvSpPr>
-            <p:cNvPr id="116" name="Texto 116"/>
+            <p:cNvPr id="115" name="Texto 115"/>
             <p:cNvSpPr txBox="1"/>
             <p:nvPr/>
           </p:nvSpPr>
@@ -20541,7 +19877,7 @@
                                           </p:stCondLst>
                                         </p:cTn>
                                         <p:tgtEl>
-                                          <p:spTgt spid="105"/>
+                                          <p:spTgt spid="104"/>
                                         </p:tgtEl>
                                         <p:attrNameLst>
                                           <p:attrName>style.visibility</p:attrName>
@@ -20555,7 +19891,7 @@
                                       <p:cBhvr>
                                         <p:cTn id="7" dur="700"/>
                                         <p:tgtEl>
-                                          <p:spTgt spid="105"/>
+                                          <p:spTgt spid="104"/>
                                         </p:tgtEl>
                                       </p:cBhvr>
                                     </p:animEffect>
@@ -20576,7 +19912,7 @@
                                           </p:stCondLst>
                                         </p:cTn>
                                         <p:tgtEl>
-                                          <p:spTgt spid="108"/>
+                                          <p:spTgt spid="107"/>
                                         </p:tgtEl>
                                         <p:attrNameLst>
                                           <p:attrName>style.visibility</p:attrName>
@@ -20590,7 +19926,7 @@
                                       <p:cBhvr>
                                         <p:cTn id="10" dur="700"/>
                                         <p:tgtEl>
-                                          <p:spTgt spid="108"/>
+                                          <p:spTgt spid="107"/>
                                         </p:tgtEl>
                                       </p:cBhvr>
                                     </p:animEffect>
@@ -20611,7 +19947,7 @@
                                           </p:stCondLst>
                                         </p:cTn>
                                         <p:tgtEl>
-                                          <p:spTgt spid="111"/>
+                                          <p:spTgt spid="110"/>
                                         </p:tgtEl>
                                         <p:attrNameLst>
                                           <p:attrName>style.visibility</p:attrName>
@@ -20625,7 +19961,7 @@
                                       <p:cBhvr>
                                         <p:cTn id="13" dur="700"/>
                                         <p:tgtEl>
-                                          <p:spTgt spid="111"/>
+                                          <p:spTgt spid="110"/>
                                         </p:tgtEl>
                                       </p:cBhvr>
                                     </p:animEffect>
@@ -20646,7 +19982,7 @@
                                           </p:stCondLst>
                                         </p:cTn>
                                         <p:tgtEl>
-                                          <p:spTgt spid="114"/>
+                                          <p:spTgt spid="113"/>
                                         </p:tgtEl>
                                         <p:attrNameLst>
                                           <p:attrName>style.visibility</p:attrName>
@@ -20660,7 +19996,7 @@
                                       <p:cBhvr>
                                         <p:cTn id="16" dur="700"/>
                                         <p:tgtEl>
-                                          <p:spTgt spid="114"/>
+                                          <p:spTgt spid="113"/>
                                         </p:tgtEl>
                                       </p:cBhvr>
                                     </p:animEffect>
@@ -20681,7 +20017,7 @@
                                           </p:stCondLst>
                                         </p:cTn>
                                         <p:tgtEl>
-                                          <p:spTgt spid="117"/>
+                                          <p:spTgt spid="116"/>
                                         </p:tgtEl>
                                         <p:attrNameLst>
                                           <p:attrName>style.visibility</p:attrName>
@@ -20695,7 +20031,7 @@
                                       <p:cBhvr>
                                         <p:cTn id="19" dur="700"/>
                                         <p:tgtEl>
-                                          <p:spTgt spid="117"/>
+                                          <p:spTgt spid="116"/>
                                         </p:tgtEl>
                                       </p:cBhvr>
                                     </p:animEffect>
@@ -20730,7 +20066,7 @@
       </p:par>
     </p:tnLst>
     <p:bldLst>
-      <p:bldP spid="105" grpId="0"/>
+      <p:bldP spid="104" grpId="0"/>
     </p:bldLst>
   </p:timing>
 </p:sld>
@@ -21400,65 +20736,7 @@
       </p:grpSp>
       <p:sp>
         <p:nvSpPr>
-          <p:cNvPr id="101" name="Cabeçalho 101"/>
-          <p:cNvSpPr txBox="1"/>
-          <p:nvPr/>
-        </p:nvSpPr>
-        <p:spPr>
-          <a:xfrm>
-            <a:off x="1024128" y="932688"/>
-            <a:ext cx="13533120" cy="411480"/>
-          </a:xfrm>
-          <a:prstGeom prst="rect">
-            <a:avLst/>
-          </a:prstGeom>
-          <a:noFill/>
-        </p:spPr>
-        <p:txBody>
-          <a:bodyPr wrap="square" lIns="0" tIns="0" rIns="0" bIns="0" anchor="t" rtlCol="0">
-            <a:noAutofit/>
-          </a:bodyPr>
-          <a:lstStyle/>
-          <a:p>
-            <a:pPr algn="l">
-              <a:spcBef>
-                <a:spcPts val="0"/>
-              </a:spcBef>
-              <a:spcAft>
-                <a:spcPts val="0"/>
-              </a:spcAft>
-              <a:buNone/>
-            </a:pPr>
-            <a:r>
-              <a:rPr lang="pt-BR" sz="1900">
-                <a:solidFill>
-                  <a:srgbClr val="3E721D"/>
-                </a:solidFill>
-                <a:latin typeface="Garet"/>
-                <a:ea typeface="Garet"/>
-                <a:cs typeface="Garet"/>
-                <a:sym typeface="Garet"/>
-              </a:rPr>
-              <a:t xml:space="preserve">Apresentado por  </a:t>
-            </a:r>
-            <a:r>
-              <a:rPr lang="pt-BR" sz="1900" b="1">
-                <a:solidFill>
-                  <a:srgbClr val="3E721D"/>
-                </a:solidFill>
-                <a:latin typeface="Garet Bold"/>
-                <a:ea typeface="Garet Bold"/>
-                <a:cs typeface="Garet Bold"/>
-                <a:sym typeface="Garet Bold"/>
-              </a:rPr>
-              <a:t>Matheus Rosa, Gabriely Paixão, Yvana Lopes, Milena Vitória e Myriam Caires</a:t>
-            </a:r>
-          </a:p>
-        </p:txBody>
-      </p:sp>
-      <p:sp>
-        <p:nvSpPr>
-          <p:cNvPr id="102" name="Ano 102"/>
+          <p:cNvPr id="101" name="Ano 101"/>
           <p:cNvSpPr txBox="1"/>
           <p:nvPr/>
         </p:nvSpPr>
@@ -21504,7 +20782,7 @@
       </p:sp>
       <p:sp>
         <p:nvSpPr>
-          <p:cNvPr id="103" name="Rodapé 103"/>
+          <p:cNvPr id="102" name="Rodapé 102"/>
           <p:cNvSpPr txBox="1"/>
           <p:nvPr/>
         </p:nvSpPr>
@@ -21550,7 +20828,7 @@
       </p:sp>
       <p:sp>
         <p:nvSpPr>
-          <p:cNvPr id="104" name="Página 104"/>
+          <p:cNvPr id="103" name="Página 103"/>
           <p:cNvSpPr txBox="1"/>
           <p:nvPr/>
         </p:nvSpPr>
@@ -21596,7 +20874,7 @@
       </p:sp>
       <p:sp>
         <p:nvSpPr>
-          <p:cNvPr id="105" name="Título 105"/>
+          <p:cNvPr id="104" name="Título 104"/>
           <p:cNvSpPr txBox="1"/>
           <p:nvPr/>
         </p:nvSpPr>
@@ -21671,7 +20949,7 @@
       </p:sp>
       <p:sp>
         <p:nvSpPr>
-          <p:cNvPr id="106" name="Texto 106"/>
+          <p:cNvPr id="105" name="Texto 105"/>
           <p:cNvSpPr txBox="1"/>
           <p:nvPr/>
         </p:nvSpPr>
@@ -21720,7 +20998,7 @@
       </p:sp>
       <p:grpSp>
         <p:nvGrpSpPr>
-          <p:cNvPr id="110" name="Item 110"/>
+          <p:cNvPr id="109" name="Item 109"/>
           <p:cNvGrpSpPr/>
           <p:nvPr/>
         </p:nvGrpSpPr>
@@ -21734,7 +21012,7 @@
         </p:grpSpPr>
         <p:sp>
           <p:nvSpPr>
-            <p:cNvPr id="107" name="Cartão 107"/>
+            <p:cNvPr id="106" name="Cartão 106"/>
             <p:cNvSpPr/>
             <p:nvPr/>
           </p:nvSpPr>
@@ -21766,7 +21044,7 @@
         </p:sp>
         <p:sp>
           <p:nvSpPr>
-            <p:cNvPr id="108" name="Texto 108"/>
+            <p:cNvPr id="107" name="Texto 107"/>
             <p:cNvSpPr txBox="1"/>
             <p:nvPr/>
           </p:nvSpPr>
@@ -21812,7 +21090,7 @@
         </p:sp>
         <p:sp>
           <p:nvSpPr>
-            <p:cNvPr id="109" name="Texto 109"/>
+            <p:cNvPr id="108" name="Texto 108"/>
             <p:cNvSpPr txBox="1"/>
             <p:nvPr/>
           </p:nvSpPr>
@@ -21910,7 +21188,7 @@
       </p:grpSp>
       <p:grpSp>
         <p:nvGrpSpPr>
-          <p:cNvPr id="114" name="Item 114"/>
+          <p:cNvPr id="113" name="Item 113"/>
           <p:cNvGrpSpPr/>
           <p:nvPr/>
         </p:nvGrpSpPr>
@@ -21924,7 +21202,7 @@
         </p:grpSpPr>
         <p:sp>
           <p:nvSpPr>
-            <p:cNvPr id="111" name="Cartão 111"/>
+            <p:cNvPr id="110" name="Cartão 110"/>
             <p:cNvSpPr/>
             <p:nvPr/>
           </p:nvSpPr>
@@ -21956,7 +21234,7 @@
         </p:sp>
         <p:sp>
           <p:nvSpPr>
-            <p:cNvPr id="112" name="Texto 112"/>
+            <p:cNvPr id="111" name="Texto 111"/>
             <p:cNvSpPr txBox="1"/>
             <p:nvPr/>
           </p:nvSpPr>
@@ -22002,7 +21280,7 @@
         </p:sp>
         <p:sp>
           <p:nvSpPr>
-            <p:cNvPr id="113" name="Texto 113"/>
+            <p:cNvPr id="112" name="Texto 112"/>
             <p:cNvSpPr txBox="1"/>
             <p:nvPr/>
           </p:nvSpPr>
@@ -22088,7 +21366,7 @@
       </p:grpSp>
       <p:grpSp>
         <p:nvGrpSpPr>
-          <p:cNvPr id="118" name="Item 118"/>
+          <p:cNvPr id="117" name="Item 117"/>
           <p:cNvGrpSpPr/>
           <p:nvPr/>
         </p:nvGrpSpPr>
@@ -22102,7 +21380,7 @@
         </p:grpSpPr>
         <p:sp>
           <p:nvSpPr>
-            <p:cNvPr id="115" name="Cartão 115"/>
+            <p:cNvPr id="114" name="Cartão 114"/>
             <p:cNvSpPr/>
             <p:nvPr/>
           </p:nvSpPr>
@@ -22134,7 +21412,7 @@
         </p:sp>
         <p:sp>
           <p:nvSpPr>
-            <p:cNvPr id="116" name="Texto 116"/>
+            <p:cNvPr id="115" name="Texto 115"/>
             <p:cNvSpPr txBox="1"/>
             <p:nvPr/>
           </p:nvSpPr>
@@ -22180,7 +21458,7 @@
         </p:sp>
         <p:sp>
           <p:nvSpPr>
-            <p:cNvPr id="117" name="Texto 117"/>
+            <p:cNvPr id="116" name="Texto 116"/>
             <p:cNvSpPr txBox="1"/>
             <p:nvPr/>
           </p:nvSpPr>
@@ -22309,7 +21587,7 @@
                                           </p:stCondLst>
                                         </p:cTn>
                                         <p:tgtEl>
-                                          <p:spTgt spid="105"/>
+                                          <p:spTgt spid="104"/>
                                         </p:tgtEl>
                                         <p:attrNameLst>
                                           <p:attrName>style.visibility</p:attrName>
@@ -22323,7 +21601,7 @@
                                       <p:cBhvr>
                                         <p:cTn id="7" dur="700"/>
                                         <p:tgtEl>
-                                          <p:spTgt spid="105"/>
+                                          <p:spTgt spid="104"/>
                                         </p:tgtEl>
                                       </p:cBhvr>
                                     </p:animEffect>
@@ -22344,7 +21622,7 @@
                                           </p:stCondLst>
                                         </p:cTn>
                                         <p:tgtEl>
-                                          <p:spTgt spid="106"/>
+                                          <p:spTgt spid="105"/>
                                         </p:tgtEl>
                                         <p:attrNameLst>
                                           <p:attrName>style.visibility</p:attrName>
@@ -22358,7 +21636,7 @@
                                       <p:cBhvr>
                                         <p:cTn id="10" dur="700"/>
                                         <p:tgtEl>
-                                          <p:spTgt spid="106"/>
+                                          <p:spTgt spid="105"/>
                                         </p:tgtEl>
                                       </p:cBhvr>
                                     </p:animEffect>
@@ -22379,7 +21657,7 @@
                                           </p:stCondLst>
                                         </p:cTn>
                                         <p:tgtEl>
-                                          <p:spTgt spid="110"/>
+                                          <p:spTgt spid="109"/>
                                         </p:tgtEl>
                                         <p:attrNameLst>
                                           <p:attrName>style.visibility</p:attrName>
@@ -22393,7 +21671,7 @@
                                       <p:cBhvr>
                                         <p:cTn id="13" dur="700"/>
                                         <p:tgtEl>
-                                          <p:spTgt spid="110"/>
+                                          <p:spTgt spid="109"/>
                                         </p:tgtEl>
                                       </p:cBhvr>
                                     </p:animEffect>
@@ -22414,7 +21692,7 @@
                                           </p:stCondLst>
                                         </p:cTn>
                                         <p:tgtEl>
-                                          <p:spTgt spid="114"/>
+                                          <p:spTgt spid="113"/>
                                         </p:tgtEl>
                                         <p:attrNameLst>
                                           <p:attrName>style.visibility</p:attrName>
@@ -22428,7 +21706,7 @@
                                       <p:cBhvr>
                                         <p:cTn id="16" dur="700"/>
                                         <p:tgtEl>
-                                          <p:spTgt spid="114"/>
+                                          <p:spTgt spid="113"/>
                                         </p:tgtEl>
                                       </p:cBhvr>
                                     </p:animEffect>
@@ -22449,7 +21727,7 @@
                                           </p:stCondLst>
                                         </p:cTn>
                                         <p:tgtEl>
-                                          <p:spTgt spid="118"/>
+                                          <p:spTgt spid="117"/>
                                         </p:tgtEl>
                                         <p:attrNameLst>
                                           <p:attrName>style.visibility</p:attrName>
@@ -22463,7 +21741,7 @@
                                       <p:cBhvr>
                                         <p:cTn id="19" dur="700"/>
                                         <p:tgtEl>
-                                          <p:spTgt spid="118"/>
+                                          <p:spTgt spid="117"/>
                                         </p:tgtEl>
                                       </p:cBhvr>
                                     </p:animEffect>
@@ -22498,8 +21776,8 @@
       </p:par>
     </p:tnLst>
     <p:bldLst>
+      <p:bldP spid="104" grpId="0"/>
       <p:bldP spid="105" grpId="0"/>
-      <p:bldP spid="106" grpId="0"/>
     </p:bldLst>
   </p:timing>
 </p:sld>
@@ -23169,65 +22447,7 @@
       </p:grpSp>
       <p:sp>
         <p:nvSpPr>
-          <p:cNvPr id="101" name="Cabeçalho 101"/>
-          <p:cNvSpPr txBox="1"/>
-          <p:nvPr/>
-        </p:nvSpPr>
-        <p:spPr>
-          <a:xfrm>
-            <a:off x="1024128" y="932688"/>
-            <a:ext cx="13533120" cy="411480"/>
-          </a:xfrm>
-          <a:prstGeom prst="rect">
-            <a:avLst/>
-          </a:prstGeom>
-          <a:noFill/>
-        </p:spPr>
-        <p:txBody>
-          <a:bodyPr wrap="square" lIns="0" tIns="0" rIns="0" bIns="0" anchor="t" rtlCol="0">
-            <a:noAutofit/>
-          </a:bodyPr>
-          <a:lstStyle/>
-          <a:p>
-            <a:pPr algn="l">
-              <a:spcBef>
-                <a:spcPts val="0"/>
-              </a:spcBef>
-              <a:spcAft>
-                <a:spcPts val="0"/>
-              </a:spcAft>
-              <a:buNone/>
-            </a:pPr>
-            <a:r>
-              <a:rPr lang="pt-BR" sz="1900">
-                <a:solidFill>
-                  <a:srgbClr val="3E721D"/>
-                </a:solidFill>
-                <a:latin typeface="Garet"/>
-                <a:ea typeface="Garet"/>
-                <a:cs typeface="Garet"/>
-                <a:sym typeface="Garet"/>
-              </a:rPr>
-              <a:t xml:space="preserve">Apresentado por  </a:t>
-            </a:r>
-            <a:r>
-              <a:rPr lang="pt-BR" sz="1900" b="1">
-                <a:solidFill>
-                  <a:srgbClr val="3E721D"/>
-                </a:solidFill>
-                <a:latin typeface="Garet Bold"/>
-                <a:ea typeface="Garet Bold"/>
-                <a:cs typeface="Garet Bold"/>
-                <a:sym typeface="Garet Bold"/>
-              </a:rPr>
-              <a:t>Matheus Rosa, Gabriely Paixão, Yvana Lopes, Milena Vitória e Myriam Caires</a:t>
-            </a:r>
-          </a:p>
-        </p:txBody>
-      </p:sp>
-      <p:sp>
-        <p:nvSpPr>
-          <p:cNvPr id="102" name="Ano 102"/>
+          <p:cNvPr id="101" name="Ano 101"/>
           <p:cNvSpPr txBox="1"/>
           <p:nvPr/>
         </p:nvSpPr>
@@ -23273,7 +22493,7 @@
       </p:sp>
       <p:sp>
         <p:nvSpPr>
-          <p:cNvPr id="103" name="Rodapé 103"/>
+          <p:cNvPr id="102" name="Rodapé 102"/>
           <p:cNvSpPr txBox="1"/>
           <p:nvPr/>
         </p:nvSpPr>
@@ -23319,7 +22539,7 @@
       </p:sp>
       <p:sp>
         <p:nvSpPr>
-          <p:cNvPr id="104" name="Página 104"/>
+          <p:cNvPr id="103" name="Página 103"/>
           <p:cNvSpPr txBox="1"/>
           <p:nvPr/>
         </p:nvSpPr>
@@ -23365,7 +22585,7 @@
       </p:sp>
       <p:sp>
         <p:nvSpPr>
-          <p:cNvPr id="105" name="Título 105"/>
+          <p:cNvPr id="104" name="Título 104"/>
           <p:cNvSpPr txBox="1"/>
           <p:nvPr/>
         </p:nvSpPr>
@@ -23414,7 +22634,7 @@
       </p:sp>
       <p:grpSp>
         <p:nvGrpSpPr>
-          <p:cNvPr id="109" name="Cartão 109"/>
+          <p:cNvPr id="108" name="Cartão 108"/>
           <p:cNvGrpSpPr/>
           <p:nvPr/>
         </p:nvGrpSpPr>
@@ -23428,7 +22648,7 @@
         </p:grpSpPr>
         <p:sp>
           <p:nvSpPr>
-            <p:cNvPr id="106" name="Cartão 106"/>
+            <p:cNvPr id="105" name="Cartão 105"/>
             <p:cNvSpPr/>
             <p:nvPr/>
           </p:nvSpPr>
@@ -23460,7 +22680,7 @@
         </p:sp>
         <p:sp>
           <p:nvSpPr>
-            <p:cNvPr id="107" name="Texto 107"/>
+            <p:cNvPr id="106" name="Texto 106"/>
             <p:cNvSpPr txBox="1"/>
             <p:nvPr/>
           </p:nvSpPr>
@@ -23506,7 +22726,7 @@
         </p:sp>
         <p:sp>
           <p:nvSpPr>
-            <p:cNvPr id="108" name="Texto 108"/>
+            <p:cNvPr id="107" name="Texto 107"/>
             <p:cNvSpPr txBox="1"/>
             <p:nvPr/>
           </p:nvSpPr>
@@ -23582,7 +22802,7 @@
       </p:grpSp>
       <p:grpSp>
         <p:nvGrpSpPr>
-          <p:cNvPr id="113" name="Cartão 113"/>
+          <p:cNvPr id="112" name="Cartão 112"/>
           <p:cNvGrpSpPr/>
           <p:nvPr/>
         </p:nvGrpSpPr>
@@ -23596,7 +22816,7 @@
         </p:grpSpPr>
         <p:sp>
           <p:nvSpPr>
-            <p:cNvPr id="110" name="Cartão 110"/>
+            <p:cNvPr id="109" name="Cartão 109"/>
             <p:cNvSpPr/>
             <p:nvPr/>
           </p:nvSpPr>
@@ -23628,7 +22848,7 @@
         </p:sp>
         <p:sp>
           <p:nvSpPr>
-            <p:cNvPr id="111" name="Texto 111"/>
+            <p:cNvPr id="110" name="Texto 110"/>
             <p:cNvSpPr txBox="1"/>
             <p:nvPr/>
           </p:nvSpPr>
@@ -23674,7 +22894,7 @@
         </p:sp>
         <p:sp>
           <p:nvSpPr>
-            <p:cNvPr id="112" name="Texto 112"/>
+            <p:cNvPr id="111" name="Texto 111"/>
             <p:cNvSpPr txBox="1"/>
             <p:nvPr/>
           </p:nvSpPr>
@@ -23750,7 +22970,7 @@
       </p:grpSp>
       <p:grpSp>
         <p:nvGrpSpPr>
-          <p:cNvPr id="117" name="Cartão 117"/>
+          <p:cNvPr id="116" name="Cartão 116"/>
           <p:cNvGrpSpPr/>
           <p:nvPr/>
         </p:nvGrpSpPr>
@@ -23764,7 +22984,7 @@
         </p:grpSpPr>
         <p:sp>
           <p:nvSpPr>
-            <p:cNvPr id="114" name="Cartão 114"/>
+            <p:cNvPr id="113" name="Cartão 113"/>
             <p:cNvSpPr/>
             <p:nvPr/>
           </p:nvSpPr>
@@ -23796,7 +23016,7 @@
         </p:sp>
         <p:sp>
           <p:nvSpPr>
-            <p:cNvPr id="115" name="Texto 115"/>
+            <p:cNvPr id="114" name="Texto 114"/>
             <p:cNvSpPr txBox="1"/>
             <p:nvPr/>
           </p:nvSpPr>
@@ -23842,7 +23062,7 @@
         </p:sp>
         <p:sp>
           <p:nvSpPr>
-            <p:cNvPr id="116" name="Texto 116"/>
+            <p:cNvPr id="115" name="Texto 115"/>
             <p:cNvSpPr txBox="1"/>
             <p:nvPr/>
           </p:nvSpPr>
@@ -23961,7 +23181,7 @@
                                           </p:stCondLst>
                                         </p:cTn>
                                         <p:tgtEl>
-                                          <p:spTgt spid="105"/>
+                                          <p:spTgt spid="104"/>
                                         </p:tgtEl>
                                         <p:attrNameLst>
                                           <p:attrName>style.visibility</p:attrName>
@@ -23975,7 +23195,7 @@
                                       <p:cBhvr>
                                         <p:cTn id="7" dur="700"/>
                                         <p:tgtEl>
-                                          <p:spTgt spid="105"/>
+                                          <p:spTgt spid="104"/>
                                         </p:tgtEl>
                                       </p:cBhvr>
                                     </p:animEffect>
@@ -23996,7 +23216,7 @@
                                           </p:stCondLst>
                                         </p:cTn>
                                         <p:tgtEl>
-                                          <p:spTgt spid="109"/>
+                                          <p:spTgt spid="108"/>
                                         </p:tgtEl>
                                         <p:attrNameLst>
                                           <p:attrName>style.visibility</p:attrName>
@@ -24010,7 +23230,7 @@
                                       <p:cBhvr>
                                         <p:cTn id="10" dur="700"/>
                                         <p:tgtEl>
-                                          <p:spTgt spid="109"/>
+                                          <p:spTgt spid="108"/>
                                         </p:tgtEl>
                                       </p:cBhvr>
                                     </p:animEffect>
@@ -24031,7 +23251,7 @@
                                           </p:stCondLst>
                                         </p:cTn>
                                         <p:tgtEl>
-                                          <p:spTgt spid="113"/>
+                                          <p:spTgt spid="112"/>
                                         </p:tgtEl>
                                         <p:attrNameLst>
                                           <p:attrName>style.visibility</p:attrName>
@@ -24045,7 +23265,7 @@
                                       <p:cBhvr>
                                         <p:cTn id="13" dur="700"/>
                                         <p:tgtEl>
-                                          <p:spTgt spid="113"/>
+                                          <p:spTgt spid="112"/>
                                         </p:tgtEl>
                                       </p:cBhvr>
                                     </p:animEffect>
@@ -24066,7 +23286,7 @@
                                           </p:stCondLst>
                                         </p:cTn>
                                         <p:tgtEl>
-                                          <p:spTgt spid="117"/>
+                                          <p:spTgt spid="116"/>
                                         </p:tgtEl>
                                         <p:attrNameLst>
                                           <p:attrName>style.visibility</p:attrName>
@@ -24080,7 +23300,7 @@
                                       <p:cBhvr>
                                         <p:cTn id="16" dur="700"/>
                                         <p:tgtEl>
-                                          <p:spTgt spid="117"/>
+                                          <p:spTgt spid="116"/>
                                         </p:tgtEl>
                                       </p:cBhvr>
                                     </p:animEffect>
@@ -24115,7 +23335,7 @@
       </p:par>
     </p:tnLst>
     <p:bldLst>
-      <p:bldP spid="105" grpId="0"/>
+      <p:bldP spid="104" grpId="0"/>
     </p:bldLst>
   </p:timing>
 </p:sld>
@@ -24785,65 +24005,7 @@
       </p:grpSp>
       <p:sp>
         <p:nvSpPr>
-          <p:cNvPr id="101" name="Cabeçalho 101"/>
-          <p:cNvSpPr txBox="1"/>
-          <p:nvPr/>
-        </p:nvSpPr>
-        <p:spPr>
-          <a:xfrm>
-            <a:off x="1024128" y="932688"/>
-            <a:ext cx="13533120" cy="411480"/>
-          </a:xfrm>
-          <a:prstGeom prst="rect">
-            <a:avLst/>
-          </a:prstGeom>
-          <a:noFill/>
-        </p:spPr>
-        <p:txBody>
-          <a:bodyPr wrap="square" lIns="0" tIns="0" rIns="0" bIns="0" anchor="t" rtlCol="0">
-            <a:noAutofit/>
-          </a:bodyPr>
-          <a:lstStyle/>
-          <a:p>
-            <a:pPr algn="l">
-              <a:spcBef>
-                <a:spcPts val="0"/>
-              </a:spcBef>
-              <a:spcAft>
-                <a:spcPts val="0"/>
-              </a:spcAft>
-              <a:buNone/>
-            </a:pPr>
-            <a:r>
-              <a:rPr lang="pt-BR" sz="1900">
-                <a:solidFill>
-                  <a:srgbClr val="3E721D"/>
-                </a:solidFill>
-                <a:latin typeface="Garet"/>
-                <a:ea typeface="Garet"/>
-                <a:cs typeface="Garet"/>
-                <a:sym typeface="Garet"/>
-              </a:rPr>
-              <a:t xml:space="preserve">Apresentado por  </a:t>
-            </a:r>
-            <a:r>
-              <a:rPr lang="pt-BR" sz="1900" b="1">
-                <a:solidFill>
-                  <a:srgbClr val="3E721D"/>
-                </a:solidFill>
-                <a:latin typeface="Garet Bold"/>
-                <a:ea typeface="Garet Bold"/>
-                <a:cs typeface="Garet Bold"/>
-                <a:sym typeface="Garet Bold"/>
-              </a:rPr>
-              <a:t>Matheus Rosa, Gabriely Paixão, Yvana Lopes, Milena Vitória e Myriam Caires</a:t>
-            </a:r>
-          </a:p>
-        </p:txBody>
-      </p:sp>
-      <p:sp>
-        <p:nvSpPr>
-          <p:cNvPr id="102" name="Ano 102"/>
+          <p:cNvPr id="101" name="Ano 101"/>
           <p:cNvSpPr txBox="1"/>
           <p:nvPr/>
         </p:nvSpPr>
@@ -24889,7 +24051,7 @@
       </p:sp>
       <p:sp>
         <p:nvSpPr>
-          <p:cNvPr id="103" name="Rodapé 103"/>
+          <p:cNvPr id="102" name="Rodapé 102"/>
           <p:cNvSpPr txBox="1"/>
           <p:nvPr/>
         </p:nvSpPr>
@@ -24935,7 +24097,7 @@
       </p:sp>
       <p:sp>
         <p:nvSpPr>
-          <p:cNvPr id="104" name="Página 104"/>
+          <p:cNvPr id="103" name="Página 103"/>
           <p:cNvSpPr txBox="1"/>
           <p:nvPr/>
         </p:nvSpPr>
@@ -24981,7 +24143,7 @@
       </p:sp>
       <p:sp>
         <p:nvSpPr>
-          <p:cNvPr id="105" name="Título 105"/>
+          <p:cNvPr id="104" name="Título 104"/>
           <p:cNvSpPr txBox="1"/>
           <p:nvPr/>
         </p:nvSpPr>
@@ -25030,7 +24192,7 @@
       </p:sp>
       <p:grpSp>
         <p:nvGrpSpPr>
-          <p:cNvPr id="108" name="Cartão 108"/>
+          <p:cNvPr id="107" name="Cartão 107"/>
           <p:cNvGrpSpPr/>
           <p:nvPr/>
         </p:nvGrpSpPr>
@@ -25044,7 +24206,7 @@
         </p:grpSpPr>
         <p:sp>
           <p:nvSpPr>
-            <p:cNvPr id="106" name="Cartão 106"/>
+            <p:cNvPr id="105" name="Cartão 105"/>
             <p:cNvSpPr/>
             <p:nvPr/>
           </p:nvSpPr>
@@ -25076,7 +24238,7 @@
         </p:sp>
         <p:sp>
           <p:nvSpPr>
-            <p:cNvPr id="107" name="Texto 107"/>
+            <p:cNvPr id="106" name="Texto 106"/>
             <p:cNvSpPr txBox="1"/>
             <p:nvPr/>
           </p:nvSpPr>
@@ -25152,7 +24314,7 @@
       </p:grpSp>
       <p:grpSp>
         <p:nvGrpSpPr>
-          <p:cNvPr id="111" name="Cartão 111"/>
+          <p:cNvPr id="110" name="Cartão 110"/>
           <p:cNvGrpSpPr/>
           <p:nvPr/>
         </p:nvGrpSpPr>
@@ -25166,7 +24328,7 @@
         </p:grpSpPr>
         <p:sp>
           <p:nvSpPr>
-            <p:cNvPr id="109" name="Cartão 109"/>
+            <p:cNvPr id="108" name="Cartão 108"/>
             <p:cNvSpPr/>
             <p:nvPr/>
           </p:nvSpPr>
@@ -25198,7 +24360,7 @@
         </p:sp>
         <p:sp>
           <p:nvSpPr>
-            <p:cNvPr id="110" name="Texto 110"/>
+            <p:cNvPr id="109" name="Texto 109"/>
             <p:cNvSpPr txBox="1"/>
             <p:nvPr/>
           </p:nvSpPr>
@@ -25298,7 +24460,7 @@
       </p:grpSp>
       <p:grpSp>
         <p:nvGrpSpPr>
-          <p:cNvPr id="114" name="Cartão 114"/>
+          <p:cNvPr id="113" name="Cartão 113"/>
           <p:cNvGrpSpPr/>
           <p:nvPr/>
         </p:nvGrpSpPr>
@@ -25312,7 +24474,7 @@
         </p:grpSpPr>
         <p:sp>
           <p:nvSpPr>
-            <p:cNvPr id="112" name="Cartão 112"/>
+            <p:cNvPr id="111" name="Cartão 111"/>
             <p:cNvSpPr/>
             <p:nvPr/>
           </p:nvSpPr>
@@ -25344,7 +24506,7 @@
         </p:sp>
         <p:sp>
           <p:nvSpPr>
-            <p:cNvPr id="113" name="Texto 113"/>
+            <p:cNvPr id="112" name="Texto 112"/>
             <p:cNvSpPr txBox="1"/>
             <p:nvPr/>
           </p:nvSpPr>
@@ -25444,7 +24606,7 @@
       </p:grpSp>
       <p:grpSp>
         <p:nvGrpSpPr>
-          <p:cNvPr id="117" name="Cartão 117"/>
+          <p:cNvPr id="116" name="Cartão 116"/>
           <p:cNvGrpSpPr/>
           <p:nvPr/>
         </p:nvGrpSpPr>
@@ -25458,7 +24620,7 @@
         </p:grpSpPr>
         <p:sp>
           <p:nvSpPr>
-            <p:cNvPr id="115" name="Cartão 115"/>
+            <p:cNvPr id="114" name="Cartão 114"/>
             <p:cNvSpPr/>
             <p:nvPr/>
           </p:nvSpPr>
@@ -25490,7 +24652,7 @@
         </p:sp>
         <p:sp>
           <p:nvSpPr>
-            <p:cNvPr id="116" name="Texto 116"/>
+            <p:cNvPr id="115" name="Texto 115"/>
             <p:cNvSpPr txBox="1"/>
             <p:nvPr/>
           </p:nvSpPr>
@@ -25609,7 +24771,7 @@
                                           </p:stCondLst>
                                         </p:cTn>
                                         <p:tgtEl>
-                                          <p:spTgt spid="105"/>
+                                          <p:spTgt spid="104"/>
                                         </p:tgtEl>
                                         <p:attrNameLst>
                                           <p:attrName>style.visibility</p:attrName>
@@ -25623,7 +24785,7 @@
                                       <p:cBhvr>
                                         <p:cTn id="7" dur="700"/>
                                         <p:tgtEl>
-                                          <p:spTgt spid="105"/>
+                                          <p:spTgt spid="104"/>
                                         </p:tgtEl>
                                       </p:cBhvr>
                                     </p:animEffect>
@@ -25644,7 +24806,7 @@
                                           </p:stCondLst>
                                         </p:cTn>
                                         <p:tgtEl>
-                                          <p:spTgt spid="108"/>
+                                          <p:spTgt spid="107"/>
                                         </p:tgtEl>
                                         <p:attrNameLst>
                                           <p:attrName>style.visibility</p:attrName>
@@ -25658,7 +24820,7 @@
                                       <p:cBhvr>
                                         <p:cTn id="10" dur="700"/>
                                         <p:tgtEl>
-                                          <p:spTgt spid="108"/>
+                                          <p:spTgt spid="107"/>
                                         </p:tgtEl>
                                       </p:cBhvr>
                                     </p:animEffect>
@@ -25679,7 +24841,7 @@
                                           </p:stCondLst>
                                         </p:cTn>
                                         <p:tgtEl>
-                                          <p:spTgt spid="111"/>
+                                          <p:spTgt spid="110"/>
                                         </p:tgtEl>
                                         <p:attrNameLst>
                                           <p:attrName>style.visibility</p:attrName>
@@ -25693,7 +24855,7 @@
                                       <p:cBhvr>
                                         <p:cTn id="13" dur="700"/>
                                         <p:tgtEl>
-                                          <p:spTgt spid="111"/>
+                                          <p:spTgt spid="110"/>
                                         </p:tgtEl>
                                       </p:cBhvr>
                                     </p:animEffect>
@@ -25714,7 +24876,7 @@
                                           </p:stCondLst>
                                         </p:cTn>
                                         <p:tgtEl>
-                                          <p:spTgt spid="114"/>
+                                          <p:spTgt spid="113"/>
                                         </p:tgtEl>
                                         <p:attrNameLst>
                                           <p:attrName>style.visibility</p:attrName>
@@ -25728,7 +24890,7 @@
                                       <p:cBhvr>
                                         <p:cTn id="16" dur="700"/>
                                         <p:tgtEl>
-                                          <p:spTgt spid="114"/>
+                                          <p:spTgt spid="113"/>
                                         </p:tgtEl>
                                       </p:cBhvr>
                                     </p:animEffect>
@@ -25749,7 +24911,7 @@
                                           </p:stCondLst>
                                         </p:cTn>
                                         <p:tgtEl>
-                                          <p:spTgt spid="117"/>
+                                          <p:spTgt spid="116"/>
                                         </p:tgtEl>
                                         <p:attrNameLst>
                                           <p:attrName>style.visibility</p:attrName>
@@ -25763,7 +24925,7 @@
                                       <p:cBhvr>
                                         <p:cTn id="19" dur="700"/>
                                         <p:tgtEl>
-                                          <p:spTgt spid="117"/>
+                                          <p:spTgt spid="116"/>
                                         </p:tgtEl>
                                       </p:cBhvr>
                                     </p:animEffect>
@@ -25798,7 +24960,7 @@
       </p:par>
     </p:tnLst>
     <p:bldLst>
-      <p:bldP spid="105" grpId="0"/>
+      <p:bldP spid="104" grpId="0"/>
     </p:bldLst>
   </p:timing>
 </p:sld>
@@ -26468,65 +25630,7 @@
       </p:grpSp>
       <p:sp>
         <p:nvSpPr>
-          <p:cNvPr id="101" name="Cabeçalho 101"/>
-          <p:cNvSpPr txBox="1"/>
-          <p:nvPr/>
-        </p:nvSpPr>
-        <p:spPr>
-          <a:xfrm>
-            <a:off x="1024128" y="932688"/>
-            <a:ext cx="13533120" cy="411480"/>
-          </a:xfrm>
-          <a:prstGeom prst="rect">
-            <a:avLst/>
-          </a:prstGeom>
-          <a:noFill/>
-        </p:spPr>
-        <p:txBody>
-          <a:bodyPr wrap="square" lIns="0" tIns="0" rIns="0" bIns="0" anchor="t" rtlCol="0">
-            <a:noAutofit/>
-          </a:bodyPr>
-          <a:lstStyle/>
-          <a:p>
-            <a:pPr algn="l">
-              <a:spcBef>
-                <a:spcPts val="0"/>
-              </a:spcBef>
-              <a:spcAft>
-                <a:spcPts val="0"/>
-              </a:spcAft>
-              <a:buNone/>
-            </a:pPr>
-            <a:r>
-              <a:rPr lang="pt-BR" sz="1900">
-                <a:solidFill>
-                  <a:srgbClr val="3E721D"/>
-                </a:solidFill>
-                <a:latin typeface="Garet"/>
-                <a:ea typeface="Garet"/>
-                <a:cs typeface="Garet"/>
-                <a:sym typeface="Garet"/>
-              </a:rPr>
-              <a:t xml:space="preserve">Apresentado por  </a:t>
-            </a:r>
-            <a:r>
-              <a:rPr lang="pt-BR" sz="1900" b="1">
-                <a:solidFill>
-                  <a:srgbClr val="3E721D"/>
-                </a:solidFill>
-                <a:latin typeface="Garet Bold"/>
-                <a:ea typeface="Garet Bold"/>
-                <a:cs typeface="Garet Bold"/>
-                <a:sym typeface="Garet Bold"/>
-              </a:rPr>
-              <a:t>Matheus Rosa, Gabriely Paixão, Yvana Lopes, Milena Vitória e Myriam Caires</a:t>
-            </a:r>
-          </a:p>
-        </p:txBody>
-      </p:sp>
-      <p:sp>
-        <p:nvSpPr>
-          <p:cNvPr id="102" name="Ano 102"/>
+          <p:cNvPr id="101" name="Ano 101"/>
           <p:cNvSpPr txBox="1"/>
           <p:nvPr/>
         </p:nvSpPr>
@@ -26572,7 +25676,7 @@
       </p:sp>
       <p:sp>
         <p:nvSpPr>
-          <p:cNvPr id="103" name="Rodapé 103"/>
+          <p:cNvPr id="102" name="Rodapé 102"/>
           <p:cNvSpPr txBox="1"/>
           <p:nvPr/>
         </p:nvSpPr>
@@ -26618,7 +25722,7 @@
       </p:sp>
       <p:sp>
         <p:nvSpPr>
-          <p:cNvPr id="104" name="Página 104"/>
+          <p:cNvPr id="103" name="Página 103"/>
           <p:cNvSpPr txBox="1"/>
           <p:nvPr/>
         </p:nvSpPr>
@@ -26664,7 +25768,7 @@
       </p:sp>
       <p:sp>
         <p:nvSpPr>
-          <p:cNvPr id="105" name="Título 105"/>
+          <p:cNvPr id="104" name="Título 104"/>
           <p:cNvSpPr txBox="1"/>
           <p:nvPr/>
         </p:nvSpPr>
@@ -26713,7 +25817,7 @@
       </p:sp>
       <p:sp>
         <p:nvSpPr>
-          <p:cNvPr id="106" name="Texto 106"/>
+          <p:cNvPr id="105" name="Texto 105"/>
           <p:cNvSpPr txBox="1"/>
           <p:nvPr/>
         </p:nvSpPr>
@@ -26786,7 +25890,7 @@
       </p:sp>
       <p:grpSp>
         <p:nvGrpSpPr>
-          <p:cNvPr id="110" name="Número 110"/>
+          <p:cNvPr id="109" name="Número 109"/>
           <p:cNvGrpSpPr/>
           <p:nvPr/>
         </p:nvGrpSpPr>
@@ -26800,7 +25904,7 @@
         </p:grpSpPr>
         <p:sp>
           <p:nvSpPr>
-            <p:cNvPr id="107" name="Cartão 107"/>
+            <p:cNvPr id="106" name="Cartão 106"/>
             <p:cNvSpPr/>
             <p:nvPr/>
           </p:nvSpPr>
@@ -26832,7 +25936,7 @@
         </p:sp>
         <p:sp>
           <p:nvSpPr>
-            <p:cNvPr id="108" name="Texto 108"/>
+            <p:cNvPr id="107" name="Texto 107"/>
             <p:cNvSpPr txBox="1"/>
             <p:nvPr/>
           </p:nvSpPr>
@@ -26878,7 +25982,7 @@
         </p:sp>
         <p:sp>
           <p:nvSpPr>
-            <p:cNvPr id="109" name="Texto 109"/>
+            <p:cNvPr id="108" name="Texto 108"/>
             <p:cNvSpPr txBox="1"/>
             <p:nvPr/>
           </p:nvSpPr>
@@ -26952,7 +26056,7 @@
       </p:grpSp>
       <p:grpSp>
         <p:nvGrpSpPr>
-          <p:cNvPr id="114" name="Número 114"/>
+          <p:cNvPr id="113" name="Número 113"/>
           <p:cNvGrpSpPr/>
           <p:nvPr/>
         </p:nvGrpSpPr>
@@ -26966,7 +26070,7 @@
         </p:grpSpPr>
         <p:sp>
           <p:nvSpPr>
-            <p:cNvPr id="111" name="Cartão 111"/>
+            <p:cNvPr id="110" name="Cartão 110"/>
             <p:cNvSpPr/>
             <p:nvPr/>
           </p:nvSpPr>
@@ -26998,7 +26102,7 @@
         </p:sp>
         <p:sp>
           <p:nvSpPr>
-            <p:cNvPr id="112" name="Texto 112"/>
+            <p:cNvPr id="111" name="Texto 111"/>
             <p:cNvSpPr txBox="1"/>
             <p:nvPr/>
           </p:nvSpPr>
@@ -27044,7 +26148,7 @@
         </p:sp>
         <p:sp>
           <p:nvSpPr>
-            <p:cNvPr id="113" name="Texto 113"/>
+            <p:cNvPr id="112" name="Texto 112"/>
             <p:cNvSpPr txBox="1"/>
             <p:nvPr/>
           </p:nvSpPr>
@@ -27094,7 +26198,7 @@
       </p:grpSp>
       <p:grpSp>
         <p:nvGrpSpPr>
-          <p:cNvPr id="118" name="Número 118"/>
+          <p:cNvPr id="117" name="Número 117"/>
           <p:cNvGrpSpPr/>
           <p:nvPr/>
         </p:nvGrpSpPr>
@@ -27108,7 +26212,7 @@
         </p:grpSpPr>
         <p:sp>
           <p:nvSpPr>
-            <p:cNvPr id="115" name="Cartão 115"/>
+            <p:cNvPr id="114" name="Cartão 114"/>
             <p:cNvSpPr/>
             <p:nvPr/>
           </p:nvSpPr>
@@ -27140,7 +26244,7 @@
         </p:sp>
         <p:sp>
           <p:nvSpPr>
-            <p:cNvPr id="116" name="Texto 116"/>
+            <p:cNvPr id="115" name="Texto 115"/>
             <p:cNvSpPr txBox="1"/>
             <p:nvPr/>
           </p:nvSpPr>
@@ -27186,7 +26290,7 @@
         </p:sp>
         <p:sp>
           <p:nvSpPr>
-            <p:cNvPr id="117" name="Texto 117"/>
+            <p:cNvPr id="116" name="Texto 116"/>
             <p:cNvSpPr txBox="1"/>
             <p:nvPr/>
           </p:nvSpPr>
@@ -27236,7 +26340,7 @@
       </p:grpSp>
       <p:sp>
         <p:nvSpPr>
-          <p:cNvPr id="119" name="Fonte 119"/>
+          <p:cNvPr id="118" name="Fonte 118"/>
           <p:cNvSpPr txBox="1"/>
           <p:nvPr/>
         </p:nvSpPr>
@@ -27325,7 +26429,7 @@
                                           </p:stCondLst>
                                         </p:cTn>
                                         <p:tgtEl>
-                                          <p:spTgt spid="105"/>
+                                          <p:spTgt spid="104"/>
                                         </p:tgtEl>
                                         <p:attrNameLst>
                                           <p:attrName>style.visibility</p:attrName>
@@ -27339,7 +26443,7 @@
                                       <p:cBhvr>
                                         <p:cTn id="7" dur="700"/>
                                         <p:tgtEl>
-                                          <p:spTgt spid="105"/>
+                                          <p:spTgt spid="104"/>
                                         </p:tgtEl>
                                       </p:cBhvr>
                                     </p:animEffect>
@@ -27360,7 +26464,7 @@
                                           </p:stCondLst>
                                         </p:cTn>
                                         <p:tgtEl>
-                                          <p:spTgt spid="106"/>
+                                          <p:spTgt spid="105"/>
                                         </p:tgtEl>
                                         <p:attrNameLst>
                                           <p:attrName>style.visibility</p:attrName>
@@ -27374,7 +26478,7 @@
                                       <p:cBhvr>
                                         <p:cTn id="10" dur="700"/>
                                         <p:tgtEl>
-                                          <p:spTgt spid="106"/>
+                                          <p:spTgt spid="105"/>
                                         </p:tgtEl>
                                       </p:cBhvr>
                                     </p:animEffect>
@@ -27395,7 +26499,7 @@
                                           </p:stCondLst>
                                         </p:cTn>
                                         <p:tgtEl>
-                                          <p:spTgt spid="110"/>
+                                          <p:spTgt spid="109"/>
                                         </p:tgtEl>
                                         <p:attrNameLst>
                                           <p:attrName>style.visibility</p:attrName>
@@ -27409,7 +26513,7 @@
                                       <p:cBhvr>
                                         <p:cTn id="13" dur="700"/>
                                         <p:tgtEl>
-                                          <p:spTgt spid="110"/>
+                                          <p:spTgt spid="109"/>
                                         </p:tgtEl>
                                       </p:cBhvr>
                                     </p:animEffect>
@@ -27430,7 +26534,7 @@
                                           </p:stCondLst>
                                         </p:cTn>
                                         <p:tgtEl>
-                                          <p:spTgt spid="114"/>
+                                          <p:spTgt spid="113"/>
                                         </p:tgtEl>
                                         <p:attrNameLst>
                                           <p:attrName>style.visibility</p:attrName>
@@ -27444,7 +26548,7 @@
                                       <p:cBhvr>
                                         <p:cTn id="16" dur="700"/>
                                         <p:tgtEl>
-                                          <p:spTgt spid="114"/>
+                                          <p:spTgt spid="113"/>
                                         </p:tgtEl>
                                       </p:cBhvr>
                                     </p:animEffect>
@@ -27465,7 +26569,7 @@
                                           </p:stCondLst>
                                         </p:cTn>
                                         <p:tgtEl>
-                                          <p:spTgt spid="118"/>
+                                          <p:spTgt spid="117"/>
                                         </p:tgtEl>
                                         <p:attrNameLst>
                                           <p:attrName>style.visibility</p:attrName>
@@ -27479,7 +26583,7 @@
                                       <p:cBhvr>
                                         <p:cTn id="19" dur="700"/>
                                         <p:tgtEl>
-                                          <p:spTgt spid="118"/>
+                                          <p:spTgt spid="117"/>
                                         </p:tgtEl>
                                       </p:cBhvr>
                                     </p:animEffect>
@@ -27514,8 +26618,8 @@
       </p:par>
     </p:tnLst>
     <p:bldLst>
+      <p:bldP spid="104" grpId="0"/>
       <p:bldP spid="105" grpId="0"/>
-      <p:bldP spid="106" grpId="0"/>
     </p:bldLst>
   </p:timing>
 </p:sld>

</xml_diff>